<commit_message>
feat: CV-A·CV-B 컴퓨터 비전 통합 (SAM 건물 추출 + SegFormer 거리뷰)
CV-A: V-World 항공사진 + Mobile-SAM zero-shot
- z=15 동작구 BBOX 48 타일 합성 → SAM → 실측 건물 30동 추출
- 더미 19동 → buildings.geojson 자동 교체로 자연그늘 정확도 ↑
- src/cv_buildings.py (V-World WMTS + Ultralytics SAM)

CV-B: Mapillary 거리뷰 + HuggingFace SegFormer
- 동작구 BBOX 4×4 분할 검색 → 1,249장 발견 → 19개 후보 격자 매핑
- CityScapes 19-class semantic segmentation
- shade_deficit = (road+sidewalk) × (1 − building − vegetation)
- Score 식 6번째 피처 (+0.15) → TOP10 평균 deficit 0.127
- src/cv_streetview.py (Mapillary API + transformers SegFormer)

기타:
- 시나리오 5개로 확장: 보행환경_중시 추가 (streetview_deficit 0.40)
- 강건 입지 5개 시나리오 공통 → 2곳 (동작대로 사당-이수 축)
- 발표자료 14장으로 확장 (CV-A·CV-B 슬라이드 추가)
- 외부 저작물(V-World 위성, Mapillary 거리뷰, SAM 가중치) .gitignore
- .env.example 추가, python-dotenv·torch·transformers 의존성

Co-Authored-By: Claude Opus 4.7 (1M context) <noreply@anthropic.com>
</commit_message>
<xml_diff>
--- a/presentation/동작구_그늘막_최종발표.pptx
+++ b/presentation/동작구_그늘막_최종발표.pptx
@@ -17,6 +17,8 @@
     <p:sldId id="265" r:id="rId16"/>
     <p:sldId id="266" r:id="rId17"/>
     <p:sldId id="267" r:id="rId18"/>
+    <p:sldId id="268" r:id="rId19"/>
+    <p:sldId id="269" r:id="rId20"/>
   </p:sldIdLst>
   <p:sldSz cx="12191695" cy="6858000" type="screen4x3"/>
   <p:notesSz cx="6858000" cy="9144000"/>
@@ -3369,6 +3371,1264 @@
 </file>
 
 <file path=ppt/slides/slide10.xml><?xml version="1.0" encoding="utf-8"?>
+<p:sld xmlns:a="http://schemas.openxmlformats.org/drawingml/2006/main" xmlns:p="http://schemas.openxmlformats.org/presentationml/2006/main" xmlns:r="http://schemas.openxmlformats.org/officeDocument/2006/relationships">
+  <p:cSld>
+    <p:spTree>
+      <p:nvGrpSpPr>
+        <p:cNvPr id="1" name=""/>
+        <p:cNvGrpSpPr/>
+        <p:nvPr/>
+      </p:nvGrpSpPr>
+      <p:grpSpPr/>
+      <p:sp>
+        <p:nvSpPr>
+          <p:cNvPr id="2" name="Rectangle 1"/>
+          <p:cNvSpPr/>
+          <p:nvPr/>
+        </p:nvSpPr>
+        <p:spPr>
+          <a:xfrm>
+            <a:off x="457200" y="457200"/>
+            <a:ext cx="109728" cy="731520"/>
+          </a:xfrm>
+          <a:prstGeom prst="rect">
+            <a:avLst/>
+          </a:prstGeom>
+          <a:solidFill>
+            <a:srgbClr val="1E88E5"/>
+          </a:solidFill>
+          <a:ln>
+            <a:noFill/>
+          </a:ln>
+        </p:spPr>
+        <p:style>
+          <a:lnRef idx="1">
+            <a:schemeClr val="accent1"/>
+          </a:lnRef>
+          <a:fillRef idx="3">
+            <a:schemeClr val="accent1"/>
+          </a:fillRef>
+          <a:effectRef idx="2">
+            <a:schemeClr val="accent1"/>
+          </a:effectRef>
+          <a:fontRef idx="minor">
+            <a:schemeClr val="lt1"/>
+          </a:fontRef>
+        </p:style>
+        <p:txBody>
+          <a:bodyPr rtlCol="0" anchor="ctr"/>
+          <a:lstStyle/>
+          <a:p>
+            <a:pPr algn="ctr"/>
+          </a:p>
+        </p:txBody>
+      </p:sp>
+      <p:sp>
+        <p:nvSpPr>
+          <p:cNvPr id="3" name="TextBox 2"/>
+          <p:cNvSpPr txBox="1"/>
+          <p:nvPr/>
+        </p:nvSpPr>
+        <p:spPr>
+          <a:xfrm>
+            <a:off x="685800" y="411480"/>
+            <a:ext cx="10972800" cy="548640"/>
+          </a:xfrm>
+          <a:prstGeom prst="rect">
+            <a:avLst/>
+          </a:prstGeom>
+          <a:noFill/>
+        </p:spPr>
+        <p:txBody>
+          <a:bodyPr wrap="square">
+            <a:spAutoFit/>
+          </a:bodyPr>
+          <a:lstStyle/>
+          <a:p>
+            <a:pPr algn="l"/>
+            <a:r>
+              <a:rPr sz="3000" b="1">
+                <a:solidFill>
+                  <a:srgbClr val="212121"/>
+                </a:solidFill>
+                <a:latin typeface="맑은 고딕"/>
+              </a:rPr>
+              <a:t>시나리오 민감도 분석 (5개 프리셋)</a:t>
+            </a:r>
+          </a:p>
+        </p:txBody>
+      </p:sp>
+      <p:sp>
+        <p:nvSpPr>
+          <p:cNvPr id="4" name="TextBox 3"/>
+          <p:cNvSpPr txBox="1"/>
+          <p:nvPr/>
+        </p:nvSpPr>
+        <p:spPr>
+          <a:xfrm>
+            <a:off x="685800" y="914400"/>
+            <a:ext cx="10972800" cy="365760"/>
+          </a:xfrm>
+          <a:prstGeom prst="rect">
+            <a:avLst/>
+          </a:prstGeom>
+          <a:noFill/>
+        </p:spPr>
+        <p:txBody>
+          <a:bodyPr wrap="square">
+            <a:spAutoFit/>
+          </a:bodyPr>
+          <a:lstStyle/>
+          <a:p>
+            <a:pPr algn="l"/>
+            <a:r>
+              <a:rPr sz="1400" b="0">
+                <a:solidFill>
+                  <a:srgbClr val="555555"/>
+                </a:solidFill>
+                <a:latin typeface="맑은 고딕"/>
+              </a:rPr>
+              <a:t>정책 관점별 가중치 × 동일 피처셋 → TOP 10 변화</a:t>
+            </a:r>
+          </a:p>
+        </p:txBody>
+      </p:sp>
+      <p:graphicFrame>
+        <p:nvGraphicFramePr>
+          <p:cNvPr id="5" name="Table 4"/>
+          <p:cNvGraphicFramePr>
+            <a:graphicFrameLocks noGrp="1"/>
+          </p:cNvGraphicFramePr>
+          <p:nvPr/>
+        </p:nvGraphicFramePr>
+        <p:xfrm>
+          <a:off x="685800" y="1737360"/>
+          <a:ext cx="10972800" cy="2743200"/>
+        </p:xfrm>
+        <a:graphic>
+          <a:graphicData uri="http://schemas.openxmlformats.org/drawingml/2006/table">
+            <a:tbl>
+              <a:tblPr firstRow="1" bandRow="1">
+                <a:tableStyleId>{5C22544A-7EE6-4342-B048-85BDC9FD1C3A}</a:tableStyleId>
+              </a:tblPr>
+              <a:tblGrid>
+                <a:gridCol w="3200400"/>
+                <a:gridCol w="3200400"/>
+                <a:gridCol w="1828800"/>
+                <a:gridCol w="2743200"/>
+              </a:tblGrid>
+              <a:tr h="457200">
+                <a:tc>
+                  <a:txBody>
+                    <a:bodyPr/>
+                    <a:lstStyle/>
+                    <a:p>
+                      <a:pPr algn="ctr"/>
+                      <a:r>
+                        <a:rPr sz="1400" b="1">
+                          <a:solidFill>
+                            <a:srgbClr val="FFFFFF"/>
+                          </a:solidFill>
+                          <a:latin typeface="맑은 고딕"/>
+                        </a:rPr>
+                        <a:t>시나리오</a:t>
+                      </a:r>
+                    </a:p>
+                  </a:txBody>
+                  <a:tcPr>
+                    <a:solidFill>
+                      <a:srgbClr val="1E88E5"/>
+                    </a:solidFill>
+                  </a:tcPr>
+                </a:tc>
+                <a:tc>
+                  <a:txBody>
+                    <a:bodyPr/>
+                    <a:lstStyle/>
+                    <a:p>
+                      <a:pPr algn="ctr"/>
+                      <a:r>
+                        <a:rPr sz="1400" b="1">
+                          <a:solidFill>
+                            <a:srgbClr val="FFFFFF"/>
+                          </a:solidFill>
+                          <a:latin typeface="맑은 고딕"/>
+                        </a:rPr>
+                        <a:t>강조</a:t>
+                      </a:r>
+                    </a:p>
+                  </a:txBody>
+                  <a:tcPr>
+                    <a:solidFill>
+                      <a:srgbClr val="1E88E5"/>
+                    </a:solidFill>
+                  </a:tcPr>
+                </a:tc>
+                <a:tc>
+                  <a:txBody>
+                    <a:bodyPr/>
+                    <a:lstStyle/>
+                    <a:p>
+                      <a:pPr algn="ctr"/>
+                      <a:r>
+                        <a:rPr sz="1400" b="1">
+                          <a:solidFill>
+                            <a:srgbClr val="FFFFFF"/>
+                          </a:solidFill>
+                          <a:latin typeface="맑은 고딕"/>
+                        </a:rPr>
+                        <a:t>최고 Score</a:t>
+                      </a:r>
+                    </a:p>
+                  </a:txBody>
+                  <a:tcPr>
+                    <a:solidFill>
+                      <a:srgbClr val="1E88E5"/>
+                    </a:solidFill>
+                  </a:tcPr>
+                </a:tc>
+                <a:tc>
+                  <a:txBody>
+                    <a:bodyPr/>
+                    <a:lstStyle/>
+                    <a:p>
+                      <a:pPr algn="ctr"/>
+                      <a:r>
+                        <a:rPr sz="1400" b="1">
+                          <a:solidFill>
+                            <a:srgbClr val="FFFFFF"/>
+                          </a:solidFill>
+                          <a:latin typeface="맑은 고딕"/>
+                        </a:rPr>
+                        <a:t>유니크</a:t>
+                      </a:r>
+                    </a:p>
+                  </a:txBody>
+                  <a:tcPr>
+                    <a:solidFill>
+                      <a:srgbClr val="1E88E5"/>
+                    </a:solidFill>
+                  </a:tcPr>
+                </a:tc>
+              </a:tr>
+              <a:tr h="457200">
+                <a:tc>
+                  <a:txBody>
+                    <a:bodyPr/>
+                    <a:lstStyle/>
+                    <a:p>
+                      <a:pPr algn="ctr"/>
+                      <a:r>
+                        <a:rPr sz="1300" b="0">
+                          <a:solidFill>
+                            <a:srgbClr val="212121"/>
+                          </a:solidFill>
+                          <a:latin typeface="맑은 고딕"/>
+                        </a:rPr>
+                        <a:t>기본</a:t>
+                      </a:r>
+                    </a:p>
+                  </a:txBody>
+                  <a:tcPr/>
+                </a:tc>
+                <a:tc>
+                  <a:txBody>
+                    <a:bodyPr/>
+                    <a:lstStyle/>
+                    <a:p>
+                      <a:pPr algn="ctr"/>
+                      <a:r>
+                        <a:rPr sz="1300" b="0">
+                          <a:solidFill>
+                            <a:srgbClr val="212121"/>
+                          </a:solidFill>
+                          <a:latin typeface="맑은 고딕"/>
+                        </a:rPr>
+                        <a:t>균형 (25/25/20)</a:t>
+                      </a:r>
+                    </a:p>
+                  </a:txBody>
+                  <a:tcPr/>
+                </a:tc>
+                <a:tc>
+                  <a:txBody>
+                    <a:bodyPr/>
+                    <a:lstStyle/>
+                    <a:p>
+                      <a:pPr algn="ctr"/>
+                      <a:r>
+                        <a:rPr sz="1300" b="0">
+                          <a:solidFill>
+                            <a:srgbClr val="212121"/>
+                          </a:solidFill>
+                          <a:latin typeface="맑은 고딕"/>
+                        </a:rPr>
+                        <a:t>0.533</a:t>
+                      </a:r>
+                    </a:p>
+                  </a:txBody>
+                  <a:tcPr/>
+                </a:tc>
+                <a:tc>
+                  <a:txBody>
+                    <a:bodyPr/>
+                    <a:lstStyle/>
+                    <a:p>
+                      <a:pPr algn="ctr"/>
+                      <a:r>
+                        <a:rPr sz="1300" b="0">
+                          <a:solidFill>
+                            <a:srgbClr val="212121"/>
+                          </a:solidFill>
+                          <a:latin typeface="맑은 고딕"/>
+                        </a:rPr>
+                        <a:t>0곳</a:t>
+                      </a:r>
+                    </a:p>
+                  </a:txBody>
+                  <a:tcPr/>
+                </a:tc>
+              </a:tr>
+              <a:tr h="457200">
+                <a:tc>
+                  <a:txBody>
+                    <a:bodyPr/>
+                    <a:lstStyle/>
+                    <a:p>
+                      <a:pPr algn="ctr"/>
+                      <a:r>
+                        <a:rPr sz="1300" b="1">
+                          <a:solidFill>
+                            <a:srgbClr val="212121"/>
+                          </a:solidFill>
+                          <a:latin typeface="맑은 고딕"/>
+                        </a:rPr>
+                        <a:t>고령자 중시</a:t>
+                      </a:r>
+                    </a:p>
+                  </a:txBody>
+                  <a:tcPr/>
+                </a:tc>
+                <a:tc>
+                  <a:txBody>
+                    <a:bodyPr/>
+                    <a:lstStyle/>
+                    <a:p>
+                      <a:pPr algn="ctr"/>
+                      <a:r>
+                        <a:rPr sz="1300" b="1">
+                          <a:solidFill>
+                            <a:srgbClr val="212121"/>
+                          </a:solidFill>
+                          <a:latin typeface="맑은 고딕"/>
+                        </a:rPr>
+                        <a:t>vuln 0.40</a:t>
+                      </a:r>
+                    </a:p>
+                  </a:txBody>
+                  <a:tcPr/>
+                </a:tc>
+                <a:tc>
+                  <a:txBody>
+                    <a:bodyPr/>
+                    <a:lstStyle/>
+                    <a:p>
+                      <a:pPr algn="ctr"/>
+                      <a:r>
+                        <a:rPr sz="1300" b="1">
+                          <a:solidFill>
+                            <a:srgbClr val="212121"/>
+                          </a:solidFill>
+                          <a:latin typeface="맑은 고딕"/>
+                        </a:rPr>
+                        <a:t>0.585</a:t>
+                      </a:r>
+                    </a:p>
+                  </a:txBody>
+                  <a:tcPr/>
+                </a:tc>
+                <a:tc>
+                  <a:txBody>
+                    <a:bodyPr/>
+                    <a:lstStyle/>
+                    <a:p>
+                      <a:pPr algn="ctr"/>
+                      <a:r>
+                        <a:rPr sz="1300" b="1">
+                          <a:solidFill>
+                            <a:srgbClr val="212121"/>
+                          </a:solidFill>
+                          <a:latin typeface="맑은 고딕"/>
+                        </a:rPr>
+                        <a:t>3곳 독점</a:t>
+                      </a:r>
+                    </a:p>
+                  </a:txBody>
+                  <a:tcPr/>
+                </a:tc>
+              </a:tr>
+              <a:tr h="457200">
+                <a:tc>
+                  <a:txBody>
+                    <a:bodyPr/>
+                    <a:lstStyle/>
+                    <a:p>
+                      <a:pPr algn="ctr"/>
+                      <a:r>
+                        <a:rPr sz="1300" b="0">
+                          <a:solidFill>
+                            <a:srgbClr val="212121"/>
+                          </a:solidFill>
+                          <a:latin typeface="맑은 고딕"/>
+                        </a:rPr>
+                        <a:t>폭염 중시</a:t>
+                      </a:r>
+                    </a:p>
+                  </a:txBody>
+                  <a:tcPr/>
+                </a:tc>
+                <a:tc>
+                  <a:txBody>
+                    <a:bodyPr/>
+                    <a:lstStyle/>
+                    <a:p>
+                      <a:pPr algn="ctr"/>
+                      <a:r>
+                        <a:rPr sz="1300" b="0">
+                          <a:solidFill>
+                            <a:srgbClr val="212121"/>
+                          </a:solidFill>
+                          <a:latin typeface="맑은 고딕"/>
+                        </a:rPr>
+                        <a:t>lst 0.40</a:t>
+                      </a:r>
+                    </a:p>
+                  </a:txBody>
+                  <a:tcPr/>
+                </a:tc>
+                <a:tc>
+                  <a:txBody>
+                    <a:bodyPr/>
+                    <a:lstStyle/>
+                    <a:p>
+                      <a:pPr algn="ctr"/>
+                      <a:r>
+                        <a:rPr sz="1300" b="0">
+                          <a:solidFill>
+                            <a:srgbClr val="212121"/>
+                          </a:solidFill>
+                          <a:latin typeface="맑은 고딕"/>
+                        </a:rPr>
+                        <a:t>0.577</a:t>
+                      </a:r>
+                    </a:p>
+                  </a:txBody>
+                  <a:tcPr/>
+                </a:tc>
+                <a:tc>
+                  <a:txBody>
+                    <a:bodyPr/>
+                    <a:lstStyle/>
+                    <a:p>
+                      <a:pPr algn="ctr"/>
+                      <a:r>
+                        <a:rPr sz="1300" b="0">
+                          <a:solidFill>
+                            <a:srgbClr val="212121"/>
+                          </a:solidFill>
+                          <a:latin typeface="맑은 고딕"/>
+                        </a:rPr>
+                        <a:t>0곳</a:t>
+                      </a:r>
+                    </a:p>
+                  </a:txBody>
+                  <a:tcPr/>
+                </a:tc>
+              </a:tr>
+              <a:tr h="457200">
+                <a:tc>
+                  <a:txBody>
+                    <a:bodyPr/>
+                    <a:lstStyle/>
+                    <a:p>
+                      <a:pPr algn="ctr"/>
+                      <a:r>
+                        <a:rPr sz="1300" b="1">
+                          <a:solidFill>
+                            <a:srgbClr val="212121"/>
+                          </a:solidFill>
+                          <a:latin typeface="맑은 고딕"/>
+                        </a:rPr>
+                        <a:t>유동인구 중시</a:t>
+                      </a:r>
+                    </a:p>
+                  </a:txBody>
+                  <a:tcPr/>
+                </a:tc>
+                <a:tc>
+                  <a:txBody>
+                    <a:bodyPr/>
+                    <a:lstStyle/>
+                    <a:p>
+                      <a:pPr algn="ctr"/>
+                      <a:r>
+                        <a:rPr sz="1300" b="1">
+                          <a:solidFill>
+                            <a:srgbClr val="212121"/>
+                          </a:solidFill>
+                          <a:latin typeface="맑은 고딕"/>
+                        </a:rPr>
+                        <a:t>pop 0.40</a:t>
+                      </a:r>
+                    </a:p>
+                  </a:txBody>
+                  <a:tcPr/>
+                </a:tc>
+                <a:tc>
+                  <a:txBody>
+                    <a:bodyPr/>
+                    <a:lstStyle/>
+                    <a:p>
+                      <a:pPr algn="ctr"/>
+                      <a:r>
+                        <a:rPr sz="1300" b="1">
+                          <a:solidFill>
+                            <a:srgbClr val="212121"/>
+                          </a:solidFill>
+                          <a:latin typeface="맑은 고딕"/>
+                        </a:rPr>
+                        <a:t>0.610</a:t>
+                      </a:r>
+                    </a:p>
+                  </a:txBody>
+                  <a:tcPr/>
+                </a:tc>
+                <a:tc>
+                  <a:txBody>
+                    <a:bodyPr/>
+                    <a:lstStyle/>
+                    <a:p>
+                      <a:pPr algn="ctr"/>
+                      <a:r>
+                        <a:rPr sz="1300" b="1">
+                          <a:solidFill>
+                            <a:srgbClr val="212121"/>
+                          </a:solidFill>
+                          <a:latin typeface="맑은 고딕"/>
+                        </a:rPr>
+                        <a:t>4곳 독점</a:t>
+                      </a:r>
+                    </a:p>
+                  </a:txBody>
+                  <a:tcPr/>
+                </a:tc>
+              </a:tr>
+              <a:tr h="457200">
+                <a:tc>
+                  <a:txBody>
+                    <a:bodyPr/>
+                    <a:lstStyle/>
+                    <a:p>
+                      <a:pPr algn="ctr"/>
+                      <a:r>
+                        <a:rPr sz="1300" b="1">
+                          <a:solidFill>
+                            <a:srgbClr val="212121"/>
+                          </a:solidFill>
+                          <a:latin typeface="맑은 고딕"/>
+                        </a:rPr>
+                        <a:t>보행환경 중시 (NEW)</a:t>
+                      </a:r>
+                    </a:p>
+                  </a:txBody>
+                  <a:tcPr/>
+                </a:tc>
+                <a:tc>
+                  <a:txBody>
+                    <a:bodyPr/>
+                    <a:lstStyle/>
+                    <a:p>
+                      <a:pPr algn="ctr"/>
+                      <a:r>
+                        <a:rPr sz="1300" b="1">
+                          <a:solidFill>
+                            <a:srgbClr val="212121"/>
+                          </a:solidFill>
+                          <a:latin typeface="맑은 고딕"/>
+                        </a:rPr>
+                        <a:t>streetview_deficit 0.40</a:t>
+                      </a:r>
+                    </a:p>
+                  </a:txBody>
+                  <a:tcPr/>
+                </a:tc>
+                <a:tc>
+                  <a:txBody>
+                    <a:bodyPr/>
+                    <a:lstStyle/>
+                    <a:p>
+                      <a:pPr algn="ctr"/>
+                      <a:r>
+                        <a:rPr sz="1300" b="1">
+                          <a:solidFill>
+                            <a:srgbClr val="212121"/>
+                          </a:solidFill>
+                          <a:latin typeface="맑은 고딕"/>
+                        </a:rPr>
+                        <a:t>0.586</a:t>
+                      </a:r>
+                    </a:p>
+                  </a:txBody>
+                  <a:tcPr/>
+                </a:tc>
+                <a:tc>
+                  <a:txBody>
+                    <a:bodyPr/>
+                    <a:lstStyle/>
+                    <a:p>
+                      <a:pPr algn="ctr"/>
+                      <a:r>
+                        <a:rPr sz="1300" b="1">
+                          <a:solidFill>
+                            <a:srgbClr val="212121"/>
+                          </a:solidFill>
+                          <a:latin typeface="맑은 고딕"/>
+                        </a:rPr>
+                        <a:t>0곳</a:t>
+                      </a:r>
+                    </a:p>
+                  </a:txBody>
+                  <a:tcPr/>
+                </a:tc>
+              </a:tr>
+            </a:tbl>
+          </a:graphicData>
+        </a:graphic>
+      </p:graphicFrame>
+      <p:sp>
+        <p:nvSpPr>
+          <p:cNvPr id="6" name="TextBox 5"/>
+          <p:cNvSpPr txBox="1"/>
+          <p:nvPr/>
+        </p:nvSpPr>
+        <p:spPr>
+          <a:xfrm>
+            <a:off x="685800" y="4754880"/>
+            <a:ext cx="10972800" cy="457200"/>
+          </a:xfrm>
+          <a:prstGeom prst="rect">
+            <a:avLst/>
+          </a:prstGeom>
+          <a:noFill/>
+        </p:spPr>
+        <p:txBody>
+          <a:bodyPr wrap="square">
+            <a:spAutoFit/>
+          </a:bodyPr>
+          <a:lstStyle/>
+          <a:p>
+            <a:pPr algn="l"/>
+            <a:r>
+              <a:rPr sz="1400" b="1">
+                <a:solidFill>
+                  <a:srgbClr val="E53935"/>
+                </a:solidFill>
+                <a:latin typeface="맑은 고딕"/>
+              </a:rPr>
+              <a:t>💡 CV-B 통합으로 "보행환경 중시" 시나리오 신규 추가 → 정책 검증 차원이 한 단계 늘어남</a:t>
+            </a:r>
+          </a:p>
+        </p:txBody>
+      </p:sp>
+      <p:sp>
+        <p:nvSpPr>
+          <p:cNvPr id="7" name="TextBox 6"/>
+          <p:cNvSpPr txBox="1"/>
+          <p:nvPr/>
+        </p:nvSpPr>
+        <p:spPr>
+          <a:xfrm>
+            <a:off x="685800" y="5303520"/>
+            <a:ext cx="10972800" cy="457200"/>
+          </a:xfrm>
+          <a:prstGeom prst="rect">
+            <a:avLst/>
+          </a:prstGeom>
+          <a:noFill/>
+        </p:spPr>
+        <p:txBody>
+          <a:bodyPr wrap="square">
+            <a:spAutoFit/>
+          </a:bodyPr>
+          <a:lstStyle/>
+          <a:p>
+            <a:pPr algn="l"/>
+            <a:r>
+              <a:rPr sz="1400" b="0">
+                <a:solidFill>
+                  <a:srgbClr val="555555"/>
+                </a:solidFill>
+                <a:latin typeface="맑은 고딕"/>
+              </a:rPr>
+              <a:t>🎯 5가지 관점 모두에서 공통 추천되는 입지가 존재 (다음 슬라이드)</a:t>
+            </a:r>
+          </a:p>
+        </p:txBody>
+      </p:sp>
+      <p:sp>
+        <p:nvSpPr>
+          <p:cNvPr id="8" name="TextBox 7"/>
+          <p:cNvSpPr txBox="1"/>
+          <p:nvPr/>
+        </p:nvSpPr>
+        <p:spPr>
+          <a:xfrm>
+            <a:off x="457200" y="6400800"/>
+            <a:ext cx="9144000" cy="365760"/>
+          </a:xfrm>
+          <a:prstGeom prst="rect">
+            <a:avLst/>
+          </a:prstGeom>
+          <a:noFill/>
+        </p:spPr>
+        <p:txBody>
+          <a:bodyPr wrap="square">
+            <a:spAutoFit/>
+          </a:bodyPr>
+          <a:lstStyle/>
+          <a:p>
+            <a:pPr algn="l"/>
+            <a:r>
+              <a:rPr sz="1000" b="0">
+                <a:solidFill>
+                  <a:srgbClr val="555555"/>
+                </a:solidFill>
+                <a:latin typeface="맑은 고딕"/>
+              </a:rPr>
+              <a:t>동작구 여름 그늘막 최적 입지 추천 시스템 · 한영재 · 2025961227</a:t>
+            </a:r>
+          </a:p>
+        </p:txBody>
+      </p:sp>
+      <p:sp>
+        <p:nvSpPr>
+          <p:cNvPr id="9" name="TextBox 8"/>
+          <p:cNvSpPr txBox="1"/>
+          <p:nvPr/>
+        </p:nvSpPr>
+        <p:spPr>
+          <a:xfrm>
+            <a:off x="11247120" y="6400800"/>
+            <a:ext cx="914400" cy="365760"/>
+          </a:xfrm>
+          <a:prstGeom prst="rect">
+            <a:avLst/>
+          </a:prstGeom>
+          <a:noFill/>
+        </p:spPr>
+        <p:txBody>
+          <a:bodyPr wrap="square">
+            <a:spAutoFit/>
+          </a:bodyPr>
+          <a:lstStyle/>
+          <a:p>
+            <a:pPr algn="r"/>
+            <a:r>
+              <a:rPr sz="1000" b="0">
+                <a:solidFill>
+                  <a:srgbClr val="555555"/>
+                </a:solidFill>
+                <a:latin typeface="맑은 고딕"/>
+              </a:rPr>
+              <a:t>10 / 14</a:t>
+            </a:r>
+          </a:p>
+        </p:txBody>
+      </p:sp>
+    </p:spTree>
+  </p:cSld>
+  <p:clrMapOvr>
+    <a:masterClrMapping/>
+  </p:clrMapOvr>
+</p:sld>
+</file>
+
+<file path=ppt/slides/slide11.xml><?xml version="1.0" encoding="utf-8"?>
+<p:sld xmlns:a="http://schemas.openxmlformats.org/drawingml/2006/main" xmlns:p="http://schemas.openxmlformats.org/presentationml/2006/main" xmlns:r="http://schemas.openxmlformats.org/officeDocument/2006/relationships">
+  <p:cSld>
+    <p:spTree>
+      <p:nvGrpSpPr>
+        <p:cNvPr id="1" name=""/>
+        <p:cNvGrpSpPr/>
+        <p:nvPr/>
+      </p:nvGrpSpPr>
+      <p:grpSpPr/>
+      <p:sp>
+        <p:nvSpPr>
+          <p:cNvPr id="2" name="Rectangle 1"/>
+          <p:cNvSpPr/>
+          <p:nvPr/>
+        </p:nvSpPr>
+        <p:spPr>
+          <a:xfrm>
+            <a:off x="457200" y="457200"/>
+            <a:ext cx="109728" cy="731520"/>
+          </a:xfrm>
+          <a:prstGeom prst="rect">
+            <a:avLst/>
+          </a:prstGeom>
+          <a:solidFill>
+            <a:srgbClr val="1E88E5"/>
+          </a:solidFill>
+          <a:ln>
+            <a:noFill/>
+          </a:ln>
+        </p:spPr>
+        <p:style>
+          <a:lnRef idx="1">
+            <a:schemeClr val="accent1"/>
+          </a:lnRef>
+          <a:fillRef idx="3">
+            <a:schemeClr val="accent1"/>
+          </a:fillRef>
+          <a:effectRef idx="2">
+            <a:schemeClr val="accent1"/>
+          </a:effectRef>
+          <a:fontRef idx="minor">
+            <a:schemeClr val="lt1"/>
+          </a:fontRef>
+        </p:style>
+        <p:txBody>
+          <a:bodyPr rtlCol="0" anchor="ctr"/>
+          <a:lstStyle/>
+          <a:p>
+            <a:pPr algn="ctr"/>
+          </a:p>
+        </p:txBody>
+      </p:sp>
+      <p:sp>
+        <p:nvSpPr>
+          <p:cNvPr id="3" name="TextBox 2"/>
+          <p:cNvSpPr txBox="1"/>
+          <p:nvPr/>
+        </p:nvSpPr>
+        <p:spPr>
+          <a:xfrm>
+            <a:off x="685800" y="411480"/>
+            <a:ext cx="10972800" cy="548640"/>
+          </a:xfrm>
+          <a:prstGeom prst="rect">
+            <a:avLst/>
+          </a:prstGeom>
+          <a:noFill/>
+        </p:spPr>
+        <p:txBody>
+          <a:bodyPr wrap="square">
+            <a:spAutoFit/>
+          </a:bodyPr>
+          <a:lstStyle/>
+          <a:p>
+            <a:pPr algn="l"/>
+            <a:r>
+              <a:rPr sz="3000" b="1">
+                <a:solidFill>
+                  <a:srgbClr val="212121"/>
+                </a:solidFill>
+                <a:latin typeface="맑은 고딕"/>
+              </a:rPr>
+              <a:t>강건 입지 · Robust Location</a:t>
+            </a:r>
+          </a:p>
+        </p:txBody>
+      </p:sp>
+      <p:sp>
+        <p:nvSpPr>
+          <p:cNvPr id="4" name="TextBox 3"/>
+          <p:cNvSpPr txBox="1"/>
+          <p:nvPr/>
+        </p:nvSpPr>
+        <p:spPr>
+          <a:xfrm>
+            <a:off x="685800" y="914400"/>
+            <a:ext cx="10972800" cy="365760"/>
+          </a:xfrm>
+          <a:prstGeom prst="rect">
+            <a:avLst/>
+          </a:prstGeom>
+          <a:noFill/>
+        </p:spPr>
+        <p:txBody>
+          <a:bodyPr wrap="square">
+            <a:spAutoFit/>
+          </a:bodyPr>
+          <a:lstStyle/>
+          <a:p>
+            <a:pPr algn="l"/>
+            <a:r>
+              <a:rPr sz="1400" b="0">
+                <a:solidFill>
+                  <a:srgbClr val="555555"/>
+                </a:solidFill>
+                <a:latin typeface="맑은 고딕"/>
+              </a:rPr>
+              <a:t>5개 시나리오 공통 추천 = 어떤 정책 관점에서도 필수</a:t>
+            </a:r>
+          </a:p>
+        </p:txBody>
+      </p:sp>
+      <p:sp>
+        <p:nvSpPr>
+          <p:cNvPr id="5" name="Rounded Rectangle 4"/>
+          <p:cNvSpPr/>
+          <p:nvPr/>
+        </p:nvSpPr>
+        <p:spPr>
+          <a:xfrm>
+            <a:off x="1828800" y="1828800"/>
+            <a:ext cx="4114800" cy="3200400"/>
+          </a:xfrm>
+          <a:prstGeom prst="roundRect">
+            <a:avLst/>
+          </a:prstGeom>
+          <a:solidFill>
+            <a:srgbClr val="FAFAFA"/>
+          </a:solidFill>
+          <a:ln w="38100">
+            <a:solidFill>
+              <a:srgbClr val="E53935"/>
+            </a:solidFill>
+          </a:ln>
+        </p:spPr>
+        <p:style>
+          <a:lnRef idx="1">
+            <a:schemeClr val="accent1"/>
+          </a:lnRef>
+          <a:fillRef idx="3">
+            <a:schemeClr val="accent1"/>
+          </a:fillRef>
+          <a:effectRef idx="2">
+            <a:schemeClr val="accent1"/>
+          </a:effectRef>
+          <a:fontRef idx="minor">
+            <a:schemeClr val="lt1"/>
+          </a:fontRef>
+        </p:style>
+        <p:txBody>
+          <a:bodyPr rtlCol="0" anchor="ctr" wrap="square" lIns="182880" tIns="274320"/>
+          <a:lstStyle/>
+          <a:p>
+            <a:pPr algn="ctr"/>
+            <a:r>
+              <a:rPr sz="1800" b="1">
+                <a:solidFill>
+                  <a:srgbClr val="E53935"/>
+                </a:solidFill>
+                <a:latin typeface="맑은 고딕"/>
+              </a:rPr>
+              <a:t>#1</a:t>
+            </a:r>
+          </a:p>
+          <a:p>
+            <a:pPr algn="ctr">
+              <a:spcBef>
+                <a:spcPts val="1000"/>
+              </a:spcBef>
+            </a:pPr>
+            <a:r>
+              <a:rPr sz="3200" b="1">
+                <a:solidFill>
+                  <a:srgbClr val="212121"/>
+                </a:solidFill>
+                <a:latin typeface="맑은 고딕"/>
+              </a:rPr>
+              <a:t>동작대로</a:t>
+            </a:r>
+          </a:p>
+          <a:p>
+            <a:pPr algn="ctr">
+              <a:spcBef>
+                <a:spcPts val="800"/>
+              </a:spcBef>
+            </a:pPr>
+            <a:r>
+              <a:rPr sz="1800" b="0">
+                <a:solidFill>
+                  <a:srgbClr val="555555"/>
+                </a:solidFill>
+                <a:latin typeface="맑은 고딕"/>
+              </a:rPr>
+              <a:t>사당-이수 축</a:t>
+            </a:r>
+          </a:p>
+          <a:p>
+            <a:pPr algn="ctr">
+              <a:spcBef>
+                <a:spcPts val="1500"/>
+              </a:spcBef>
+            </a:pPr>
+            <a:r>
+              <a:rPr sz="1300" b="0">
+                <a:solidFill>
+                  <a:srgbClr val="555555"/>
+                </a:solidFill>
+                <a:latin typeface="맑은 고딕"/>
+              </a:rPr>
+              <a:t>37.4907, 126.9647</a:t>
+            </a:r>
+          </a:p>
+        </p:txBody>
+      </p:sp>
+      <p:sp>
+        <p:nvSpPr>
+          <p:cNvPr id="6" name="Rounded Rectangle 5"/>
+          <p:cNvSpPr/>
+          <p:nvPr/>
+        </p:nvSpPr>
+        <p:spPr>
+          <a:xfrm>
+            <a:off x="6309360" y="1828800"/>
+            <a:ext cx="4114800" cy="3200400"/>
+          </a:xfrm>
+          <a:prstGeom prst="roundRect">
+            <a:avLst/>
+          </a:prstGeom>
+          <a:solidFill>
+            <a:srgbClr val="FAFAFA"/>
+          </a:solidFill>
+          <a:ln w="38100">
+            <a:solidFill>
+              <a:srgbClr val="E53935"/>
+            </a:solidFill>
+          </a:ln>
+        </p:spPr>
+        <p:style>
+          <a:lnRef idx="1">
+            <a:schemeClr val="accent1"/>
+          </a:lnRef>
+          <a:fillRef idx="3">
+            <a:schemeClr val="accent1"/>
+          </a:fillRef>
+          <a:effectRef idx="2">
+            <a:schemeClr val="accent1"/>
+          </a:effectRef>
+          <a:fontRef idx="minor">
+            <a:schemeClr val="lt1"/>
+          </a:fontRef>
+        </p:style>
+        <p:txBody>
+          <a:bodyPr rtlCol="0" anchor="ctr" wrap="square" lIns="182880" tIns="274320"/>
+          <a:lstStyle/>
+          <a:p>
+            <a:pPr algn="ctr"/>
+            <a:r>
+              <a:rPr sz="1800" b="1">
+                <a:solidFill>
+                  <a:srgbClr val="E53935"/>
+                </a:solidFill>
+                <a:latin typeface="맑은 고딕"/>
+              </a:rPr>
+              <a:t>#2</a:t>
+            </a:r>
+          </a:p>
+          <a:p>
+            <a:pPr algn="ctr">
+              <a:spcBef>
+                <a:spcPts val="1000"/>
+              </a:spcBef>
+            </a:pPr>
+            <a:r>
+              <a:rPr sz="3200" b="1">
+                <a:solidFill>
+                  <a:srgbClr val="212121"/>
+                </a:solidFill>
+                <a:latin typeface="맑은 고딕"/>
+              </a:rPr>
+              <a:t>동작대로</a:t>
+            </a:r>
+          </a:p>
+          <a:p>
+            <a:pPr algn="ctr">
+              <a:spcBef>
+                <a:spcPts val="800"/>
+              </a:spcBef>
+            </a:pPr>
+            <a:r>
+              <a:rPr sz="1800" b="0">
+                <a:solidFill>
+                  <a:srgbClr val="555555"/>
+                </a:solidFill>
+                <a:latin typeface="맑은 고딕"/>
+              </a:rPr>
+              <a:t>사당역 인근</a:t>
+            </a:r>
+          </a:p>
+          <a:p>
+            <a:pPr algn="ctr">
+              <a:spcBef>
+                <a:spcPts val="1500"/>
+              </a:spcBef>
+            </a:pPr>
+            <a:r>
+              <a:rPr sz="1300" b="0">
+                <a:solidFill>
+                  <a:srgbClr val="555555"/>
+                </a:solidFill>
+                <a:latin typeface="맑은 고딕"/>
+              </a:rPr>
+              <a:t>37.4898, 126.9670</a:t>
+            </a:r>
+          </a:p>
+        </p:txBody>
+      </p:sp>
+      <p:sp>
+        <p:nvSpPr>
+          <p:cNvPr id="7" name="TextBox 6"/>
+          <p:cNvSpPr txBox="1"/>
+          <p:nvPr/>
+        </p:nvSpPr>
+        <p:spPr>
+          <a:xfrm>
+            <a:off x="685800" y="5303520"/>
+            <a:ext cx="10972800" cy="457200"/>
+          </a:xfrm>
+          <a:prstGeom prst="rect">
+            <a:avLst/>
+          </a:prstGeom>
+          <a:noFill/>
+        </p:spPr>
+        <p:txBody>
+          <a:bodyPr wrap="square">
+            <a:spAutoFit/>
+          </a:bodyPr>
+          <a:lstStyle/>
+          <a:p>
+            <a:pPr algn="ctr"/>
+            <a:r>
+              <a:rPr sz="1600" b="1">
+                <a:solidFill>
+                  <a:srgbClr val="1E88E5"/>
+                </a:solidFill>
+                <a:latin typeface="맑은 고딕"/>
+              </a:rPr>
+              <a:t>정책적 함의: 예산 제약 시 이 2곳이 최우선 설치 대상</a:t>
+            </a:r>
+          </a:p>
+        </p:txBody>
+      </p:sp>
+      <p:sp>
+        <p:nvSpPr>
+          <p:cNvPr id="8" name="TextBox 7"/>
+          <p:cNvSpPr txBox="1"/>
+          <p:nvPr/>
+        </p:nvSpPr>
+        <p:spPr>
+          <a:xfrm>
+            <a:off x="685800" y="5852160"/>
+            <a:ext cx="10972800" cy="457200"/>
+          </a:xfrm>
+          <a:prstGeom prst="rect">
+            <a:avLst/>
+          </a:prstGeom>
+          <a:noFill/>
+        </p:spPr>
+        <p:txBody>
+          <a:bodyPr wrap="square">
+            <a:spAutoFit/>
+          </a:bodyPr>
+          <a:lstStyle/>
+          <a:p>
+            <a:pPr algn="ctr"/>
+            <a:r>
+              <a:rPr sz="1300" b="0">
+                <a:solidFill>
+                  <a:srgbClr val="555555"/>
+                </a:solidFill>
+                <a:latin typeface="맑은 고딕"/>
+              </a:rPr>
+              <a:t>CV-B 보행환경 시나리오까지 통과한 입지 → 더 까다로운 검증 통과</a:t>
+            </a:r>
+          </a:p>
+        </p:txBody>
+      </p:sp>
+      <p:sp>
+        <p:nvSpPr>
+          <p:cNvPr id="9" name="TextBox 8"/>
+          <p:cNvSpPr txBox="1"/>
+          <p:nvPr/>
+        </p:nvSpPr>
+        <p:spPr>
+          <a:xfrm>
+            <a:off x="457200" y="6400800"/>
+            <a:ext cx="9144000" cy="365760"/>
+          </a:xfrm>
+          <a:prstGeom prst="rect">
+            <a:avLst/>
+          </a:prstGeom>
+          <a:noFill/>
+        </p:spPr>
+        <p:txBody>
+          <a:bodyPr wrap="square">
+            <a:spAutoFit/>
+          </a:bodyPr>
+          <a:lstStyle/>
+          <a:p>
+            <a:pPr algn="l"/>
+            <a:r>
+              <a:rPr sz="1000" b="0">
+                <a:solidFill>
+                  <a:srgbClr val="555555"/>
+                </a:solidFill>
+                <a:latin typeface="맑은 고딕"/>
+              </a:rPr>
+              <a:t>동작구 여름 그늘막 최적 입지 추천 시스템 · 한영재 · 2025961227</a:t>
+            </a:r>
+          </a:p>
+        </p:txBody>
+      </p:sp>
+      <p:sp>
+        <p:nvSpPr>
+          <p:cNvPr id="10" name="TextBox 9"/>
+          <p:cNvSpPr txBox="1"/>
+          <p:nvPr/>
+        </p:nvSpPr>
+        <p:spPr>
+          <a:xfrm>
+            <a:off x="11247120" y="6400800"/>
+            <a:ext cx="914400" cy="365760"/>
+          </a:xfrm>
+          <a:prstGeom prst="rect">
+            <a:avLst/>
+          </a:prstGeom>
+          <a:noFill/>
+        </p:spPr>
+        <p:txBody>
+          <a:bodyPr wrap="square">
+            <a:spAutoFit/>
+          </a:bodyPr>
+          <a:lstStyle/>
+          <a:p>
+            <a:pPr algn="r"/>
+            <a:r>
+              <a:rPr sz="1000" b="0">
+                <a:solidFill>
+                  <a:srgbClr val="555555"/>
+                </a:solidFill>
+                <a:latin typeface="맑은 고딕"/>
+              </a:rPr>
+              <a:t>11 / 14</a:t>
+            </a:r>
+          </a:p>
+        </p:txBody>
+      </p:sp>
+    </p:spTree>
+  </p:cSld>
+  <p:clrMapOvr>
+    <a:masterClrMapping/>
+  </p:clrMapOvr>
+</p:sld>
+</file>
+
+<file path=ppt/slides/slide12.xml><?xml version="1.0" encoding="utf-8"?>
 <p:sld xmlns:a="http://schemas.openxmlformats.org/drawingml/2006/main" xmlns:p="http://schemas.openxmlformats.org/presentationml/2006/main" xmlns:r="http://schemas.openxmlformats.org/officeDocument/2006/relationships">
   <p:cSld>
     <p:spTree>
@@ -4029,7 +5289,7 @@
                 </a:solidFill>
                 <a:latin typeface="맑은 고딕"/>
               </a:rPr>
-              <a:t>10 / 12</a:t>
+              <a:t>12 / 14</a:t>
             </a:r>
           </a:p>
         </p:txBody>
@@ -4042,7 +5302,7 @@
 </p:sld>
 </file>
 
-<file path=ppt/slides/slide11.xml><?xml version="1.0" encoding="utf-8"?>
+<file path=ppt/slides/slide13.xml><?xml version="1.0" encoding="utf-8"?>
 <p:sld xmlns:a="http://schemas.openxmlformats.org/drawingml/2006/main" xmlns:p="http://schemas.openxmlformats.org/presentationml/2006/main" xmlns:r="http://schemas.openxmlformats.org/officeDocument/2006/relationships">
   <p:cSld>
     <p:spTree>
@@ -4389,7 +5649,7 @@
                 </a:solidFill>
                 <a:latin typeface="맑은 고딕"/>
               </a:rPr>
-              <a:t>11 / 12</a:t>
+              <a:t>13 / 14</a:t>
             </a:r>
           </a:p>
         </p:txBody>
@@ -4402,7 +5662,7 @@
 </p:sld>
 </file>
 
-<file path=ppt/slides/slide12.xml><?xml version="1.0" encoding="utf-8"?>
+<file path=ppt/slides/slide14.xml><?xml version="1.0" encoding="utf-8"?>
 <p:sld xmlns:a="http://schemas.openxmlformats.org/drawingml/2006/main" xmlns:p="http://schemas.openxmlformats.org/presentationml/2006/main" xmlns:r="http://schemas.openxmlformats.org/officeDocument/2006/relationships">
   <p:cSld>
     <p:spTree>
@@ -4775,29 +6035,41 @@
           <a:p>
             <a:pPr algn="ctr"/>
             <a:r>
-              <a:rPr sz="2000" b="1">
+              <a:rPr sz="1800" b="1">
                 <a:solidFill>
                   <a:srgbClr val="FFEE58"/>
                 </a:solidFill>
                 <a:latin typeface="맑은 고딕"/>
               </a:rPr>
-              <a:t>데이터의 논리로, 어떤 정책 관점을 취하든 그늘막이 반드시 필요한 3곳을 찾아냈다.</a:t>
+              <a:t>항공사진과 거리뷰까지 컴퓨터 비전으로 읽어내,</a:t>
+            </a:r>
+          </a:p>
+          <a:p>
+            <a:pPr algn="ctr"/>
+            <a:r>
+              <a:rPr sz="1800" b="1">
+                <a:solidFill>
+                  <a:srgbClr val="FFEE58"/>
+                </a:solidFill>
+                <a:latin typeface="맑은 고딕"/>
+              </a:rPr>
+              <a:t>5가지 정책 관점 모두에서 살아남는 강건 입지 2곳을 찾아냈다.</a:t>
             </a:r>
           </a:p>
           <a:p>
             <a:pPr algn="ctr">
               <a:spcBef>
-                <a:spcPts val="600"/>
+                <a:spcPts val="800"/>
               </a:spcBef>
             </a:pPr>
             <a:r>
-              <a:rPr sz="1400" b="0">
+              <a:rPr sz="1200" b="0">
                 <a:solidFill>
                   <a:srgbClr val="CCCCCC"/>
                 </a:solidFill>
                 <a:latin typeface="맑은 고딕"/>
               </a:rPr>
-              <a:t>— 자연그늘 페널티까지 반영해 식별력을 한 단계 더 엄격하게.</a:t>
+              <a:t>— SAM(항공) + SegFormer(거리뷰) + MCDA 가중합 + 시나리오 민감도</a:t>
             </a:r>
           </a:p>
         </p:txBody>
@@ -4867,7 +6139,7 @@
                 </a:solidFill>
                 <a:latin typeface="맑은 고딕"/>
               </a:rPr>
-              <a:t>12 / 12</a:t>
+              <a:t>14 / 14</a:t>
             </a:r>
           </a:p>
         </p:txBody>
@@ -5241,7 +6513,7 @@
                 </a:solidFill>
                 <a:latin typeface="맑은 고딕"/>
               </a:rPr>
-              <a:t>2 / 12</a:t>
+              <a:t>2 / 14</a:t>
             </a:r>
           </a:p>
         </p:txBody>
@@ -6030,7 +7302,7 @@
                 </a:solidFill>
                 <a:latin typeface="맑은 고딕"/>
               </a:rPr>
-              <a:t>3 / 12</a:t>
+              <a:t>3 / 14</a:t>
             </a:r>
           </a:p>
         </p:txBody>
@@ -6641,7 +7913,7 @@
                 </a:solidFill>
                 <a:latin typeface="맑은 고딕"/>
               </a:rPr>
-              <a:t>4 / 12</a:t>
+              <a:t>4 / 14</a:t>
             </a:r>
           </a:p>
         </p:txBody>
@@ -6786,7 +8058,7 @@
         <p:spPr>
           <a:xfrm>
             <a:off x="685800" y="1737360"/>
-            <a:ext cx="10972800" cy="1188720"/>
+            <a:ext cx="10972800" cy="1463040"/>
           </a:xfrm>
           <a:prstGeom prst="roundRect">
             <a:avLst/>
@@ -6818,13 +8090,25 @@
           <a:p>
             <a:pPr algn="ctr"/>
             <a:r>
-              <a:rPr sz="2200" b="1">
+              <a:rPr sz="2000" b="1">
                 <a:solidFill>
                   <a:srgbClr val="FFEE58"/>
                 </a:solidFill>
                 <a:latin typeface="맑은 고딕"/>
               </a:rPr>
-              <a:t>Score = 0.30·popdens + 0.30·lst + 0.20·vuln − 0.15·shade − 0.05·natural</a:t>
+              <a:t>Score = 0.25·popdens + 0.25·lst + 0.20·vuln</a:t>
+            </a:r>
+          </a:p>
+          <a:p>
+            <a:pPr algn="ctr"/>
+            <a:r>
+              <a:rPr sz="2000" b="1">
+                <a:solidFill>
+                  <a:srgbClr val="FFEE58"/>
+                </a:solidFill>
+                <a:latin typeface="맑은 고딕"/>
+              </a:rPr>
+              <a:t>− 0.15·shade − 0.05·natural + 0.15·streetview_deficit</a:t>
             </a:r>
           </a:p>
         </p:txBody>
@@ -6837,7 +8121,7 @@
         </p:nvSpPr>
         <p:spPr>
           <a:xfrm>
-            <a:off x="685800" y="3108960"/>
+            <a:off x="685800" y="3383280"/>
             <a:ext cx="10972800" cy="2103120"/>
           </a:xfrm>
           <a:prstGeom prst="rect">
@@ -6857,13 +8141,13 @@
               </a:spcAft>
             </a:pPr>
             <a:r>
-              <a:rPr sz="1600" b="0">
+              <a:rPr sz="1500" b="0">
                 <a:solidFill>
                   <a:srgbClr val="212121"/>
                 </a:solidFill>
                 <a:latin typeface="맑은 고딕"/>
               </a:rPr>
-              <a:t>• popdens (+0.30) — 시간대 가중 유동인구 (9~18시, 오후 1~3시 1.0 피크)</a:t>
+              <a:t>• popdens (+0.25) — 시간대 가중 유동인구 (오후 1~3시 1.0 피크)</a:t>
             </a:r>
           </a:p>
           <a:p>
@@ -6873,13 +8157,13 @@
               </a:spcAft>
             </a:pPr>
             <a:r>
-              <a:rPr sz="1600" b="0">
+              <a:rPr sz="1500" b="0">
                 <a:solidFill>
                   <a:srgbClr val="212121"/>
                 </a:solidFill>
                 <a:latin typeface="맑은 고딕"/>
               </a:rPr>
-              <a:t>• lst (+0.30) — 지표면 온도, 오후 피크 시간대 가중 평균</a:t>
+              <a:t>• lst (+0.25) — 지표면 온도, 오후 피크 가중 평균</a:t>
             </a:r>
           </a:p>
           <a:p>
@@ -6889,7 +8173,7 @@
               </a:spcAft>
             </a:pPr>
             <a:r>
-              <a:rPr sz="1600" b="0">
+              <a:rPr sz="1500" b="0">
                 <a:solidFill>
                   <a:srgbClr val="212121"/>
                 </a:solidFill>
@@ -6905,13 +8189,13 @@
               </a:spcAft>
             </a:pPr>
             <a:r>
-              <a:rPr sz="1600" b="0">
+              <a:rPr sz="1500" b="0">
                 <a:solidFill>
                   <a:srgbClr val="212121"/>
                 </a:solidFill>
                 <a:latin typeface="맑은 고딕"/>
               </a:rPr>
-              <a:t>• shade (−0.15) — 기존 그늘막 반경 150m 내 커버리지 (이미 된 곳은 감점)</a:t>
+              <a:t>• shade (−0.15) — 기존 그늘막 반경 150m 내 커버리지</a:t>
             </a:r>
           </a:p>
           <a:p>
@@ -6921,13 +8205,29 @@
               </a:spcAft>
             </a:pPr>
             <a:r>
-              <a:rPr sz="1600" b="0">
+              <a:rPr sz="1500" b="0">
                 <a:solidFill>
                   <a:srgbClr val="212121"/>
                 </a:solidFill>
                 <a:latin typeface="맑은 고딕"/>
               </a:rPr>
-              <a:t>• natural (−0.05) — 건물 그림자 커버 비율 (자연 그늘 페널티, 신규 활성화)</a:t>
+              <a:t>• natural (−0.05) — CV-A SAM 추출 건물 그림자 시뮬레이션</a:t>
+            </a:r>
+          </a:p>
+          <a:p>
+            <a:pPr>
+              <a:spcAft>
+                <a:spcPts val="600"/>
+              </a:spcAft>
+            </a:pPr>
+            <a:r>
+              <a:rPr sz="1500" b="0">
+                <a:solidFill>
+                  <a:srgbClr val="212121"/>
+                </a:solidFill>
+                <a:latin typeface="맑은 고딕"/>
+              </a:rPr>
+              <a:t>• streetview_deficit (+0.15) — CV-B SegFormer 거리뷰 그늘 결핍 (NEW)</a:t>
             </a:r>
           </a:p>
         </p:txBody>
@@ -7032,7 +8332,7 @@
                 </a:solidFill>
                 <a:latin typeface="맑은 고딕"/>
               </a:rPr>
-              <a:t>5 / 12</a:t>
+              <a:t>5 / 14</a:t>
             </a:r>
           </a:p>
         </p:txBody>
@@ -7543,7 +8843,7 @@
                 </a:solidFill>
                 <a:latin typeface="맑은 고딕"/>
               </a:rPr>
-              <a:t>6 / 12</a:t>
+              <a:t>6 / 14</a:t>
             </a:r>
           </a:p>
         </p:txBody>
@@ -7639,7 +8939,7 @@
                 </a:solidFill>
                 <a:latin typeface="맑은 고딕"/>
               </a:rPr>
-              <a:t>자연 그늘 시뮬레이션 (신규)</a:t>
+              <a:t>자연 그늘 시뮬레이션</a:t>
             </a:r>
           </a:p>
         </p:txBody>
@@ -7777,23 +9077,7 @@
                 </a:solidFill>
                 <a:latin typeface="맑은 고딕"/>
               </a:rPr>
-              <a:t>• 효과 검증: 강건 입지 4 → 3곳, 상도로 TOP5 0.395 → 0.382</a:t>
-            </a:r>
-          </a:p>
-          <a:p>
-            <a:pPr>
-              <a:spcAft>
-                <a:spcPts val="600"/>
-              </a:spcAft>
-            </a:pPr>
-            <a:r>
-              <a:rPr sz="1500" b="0">
-                <a:solidFill>
-                  <a:srgbClr val="212121"/>
-                </a:solidFill>
-                <a:latin typeface="맑은 고딕"/>
-              </a:rPr>
-              <a:t>• 실데이터(buildings.geojson) 확보 시 자동 교체 구조</a:t>
+              <a:t>• 건물 입력은 다음 슬라이드의 CV-A로 자동 교체됨</a:t>
             </a:r>
           </a:p>
         </p:txBody>
@@ -7918,7 +9202,7 @@
                 </a:solidFill>
                 <a:latin typeface="맑은 고딕"/>
               </a:rPr>
-              <a:t>7 / 12</a:t>
+              <a:t>7 / 14</a:t>
             </a:r>
           </a:p>
         </p:txBody>
@@ -8014,7 +9298,7 @@
                 </a:solidFill>
                 <a:latin typeface="맑은 고딕"/>
               </a:rPr>
-              <a:t>시나리오 민감도 분석</a:t>
+              <a:t>CV-A · 위성 항공사진 + Mobile-SAM</a:t>
             </a:r>
           </a:p>
         </p:txBody>
@@ -8049,455 +9333,21 @@
                 </a:solidFill>
                 <a:latin typeface="맑은 고딕"/>
               </a:rPr>
-              <a:t>정책 관점별 가중치 프리셋 × 동일 피처셋 → TOP 10 변화</a:t>
-            </a:r>
-          </a:p>
-        </p:txBody>
-      </p:sp>
-      <p:graphicFrame>
-        <p:nvGraphicFramePr>
-          <p:cNvPr id="5" name="Table 4"/>
-          <p:cNvGraphicFramePr>
-            <a:graphicFrameLocks noGrp="1"/>
-          </p:cNvGraphicFramePr>
-          <p:nvPr/>
-        </p:nvGraphicFramePr>
-        <p:xfrm>
-          <a:off x="685800" y="1737360"/>
-          <a:ext cx="10972800" cy="2560320"/>
-        </p:xfrm>
-        <a:graphic>
-          <a:graphicData uri="http://schemas.openxmlformats.org/drawingml/2006/table">
-            <a:tbl>
-              <a:tblPr firstRow="1" bandRow="1">
-                <a:tableStyleId>{5C22544A-7EE6-4342-B048-85BDC9FD1C3A}</a:tableStyleId>
-              </a:tblPr>
-              <a:tblGrid>
-                <a:gridCol w="2743200"/>
-                <a:gridCol w="3200400"/>
-                <a:gridCol w="2286000"/>
-                <a:gridCol w="2743200"/>
-              </a:tblGrid>
-              <a:tr h="512064">
-                <a:tc>
-                  <a:txBody>
-                    <a:bodyPr/>
-                    <a:lstStyle/>
-                    <a:p>
-                      <a:pPr algn="ctr"/>
-                      <a:r>
-                        <a:rPr sz="1400" b="1">
-                          <a:solidFill>
-                            <a:srgbClr val="FFFFFF"/>
-                          </a:solidFill>
-                          <a:latin typeface="맑은 고딕"/>
-                        </a:rPr>
-                        <a:t>시나리오</a:t>
-                      </a:r>
-                    </a:p>
-                  </a:txBody>
-                  <a:tcPr>
-                    <a:solidFill>
-                      <a:srgbClr val="1E88E5"/>
-                    </a:solidFill>
-                  </a:tcPr>
-                </a:tc>
-                <a:tc>
-                  <a:txBody>
-                    <a:bodyPr/>
-                    <a:lstStyle/>
-                    <a:p>
-                      <a:pPr algn="ctr"/>
-                      <a:r>
-                        <a:rPr sz="1400" b="1">
-                          <a:solidFill>
-                            <a:srgbClr val="FFFFFF"/>
-                          </a:solidFill>
-                          <a:latin typeface="맑은 고딕"/>
-                        </a:rPr>
-                        <a:t>강조</a:t>
-                      </a:r>
-                    </a:p>
-                  </a:txBody>
-                  <a:tcPr>
-                    <a:solidFill>
-                      <a:srgbClr val="1E88E5"/>
-                    </a:solidFill>
-                  </a:tcPr>
-                </a:tc>
-                <a:tc>
-                  <a:txBody>
-                    <a:bodyPr/>
-                    <a:lstStyle/>
-                    <a:p>
-                      <a:pPr algn="ctr"/>
-                      <a:r>
-                        <a:rPr sz="1400" b="1">
-                          <a:solidFill>
-                            <a:srgbClr val="FFFFFF"/>
-                          </a:solidFill>
-                          <a:latin typeface="맑은 고딕"/>
-                        </a:rPr>
-                        <a:t>최고 Score</a:t>
-                      </a:r>
-                    </a:p>
-                  </a:txBody>
-                  <a:tcPr>
-                    <a:solidFill>
-                      <a:srgbClr val="1E88E5"/>
-                    </a:solidFill>
-                  </a:tcPr>
-                </a:tc>
-                <a:tc>
-                  <a:txBody>
-                    <a:bodyPr/>
-                    <a:lstStyle/>
-                    <a:p>
-                      <a:pPr algn="ctr"/>
-                      <a:r>
-                        <a:rPr sz="1400" b="1">
-                          <a:solidFill>
-                            <a:srgbClr val="FFFFFF"/>
-                          </a:solidFill>
-                          <a:latin typeface="맑은 고딕"/>
-                        </a:rPr>
-                        <a:t>유니크</a:t>
-                      </a:r>
-                    </a:p>
-                  </a:txBody>
-                  <a:tcPr>
-                    <a:solidFill>
-                      <a:srgbClr val="1E88E5"/>
-                    </a:solidFill>
-                  </a:tcPr>
-                </a:tc>
-              </a:tr>
-              <a:tr h="512064">
-                <a:tc>
-                  <a:txBody>
-                    <a:bodyPr/>
-                    <a:lstStyle/>
-                    <a:p>
-                      <a:pPr algn="ctr"/>
-                      <a:r>
-                        <a:rPr sz="1400" b="0">
-                          <a:solidFill>
-                            <a:srgbClr val="212121"/>
-                          </a:solidFill>
-                          <a:latin typeface="맑은 고딕"/>
-                        </a:rPr>
-                        <a:t>기본</a:t>
-                      </a:r>
-                    </a:p>
-                  </a:txBody>
-                  <a:tcPr/>
-                </a:tc>
-                <a:tc>
-                  <a:txBody>
-                    <a:bodyPr/>
-                    <a:lstStyle/>
-                    <a:p>
-                      <a:pPr algn="ctr"/>
-                      <a:r>
-                        <a:rPr sz="1400" b="0">
-                          <a:solidFill>
-                            <a:srgbClr val="212121"/>
-                          </a:solidFill>
-                          <a:latin typeface="맑은 고딕"/>
-                        </a:rPr>
-                        <a:t>균형 (30/30/20)</a:t>
-                      </a:r>
-                    </a:p>
-                  </a:txBody>
-                  <a:tcPr/>
-                </a:tc>
-                <a:tc>
-                  <a:txBody>
-                    <a:bodyPr/>
-                    <a:lstStyle/>
-                    <a:p>
-                      <a:pPr algn="ctr"/>
-                      <a:r>
-                        <a:rPr sz="1400" b="0">
-                          <a:solidFill>
-                            <a:srgbClr val="212121"/>
-                          </a:solidFill>
-                          <a:latin typeface="맑은 고딕"/>
-                        </a:rPr>
-                        <a:t>0.574</a:t>
-                      </a:r>
-                    </a:p>
-                  </a:txBody>
-                  <a:tcPr/>
-                </a:tc>
-                <a:tc>
-                  <a:txBody>
-                    <a:bodyPr/>
-                    <a:lstStyle/>
-                    <a:p>
-                      <a:pPr algn="ctr"/>
-                      <a:r>
-                        <a:rPr sz="1400" b="0">
-                          <a:solidFill>
-                            <a:srgbClr val="212121"/>
-                          </a:solidFill>
-                          <a:latin typeface="맑은 고딕"/>
-                        </a:rPr>
-                        <a:t>0곳</a:t>
-                      </a:r>
-                    </a:p>
-                  </a:txBody>
-                  <a:tcPr/>
-                </a:tc>
-              </a:tr>
-              <a:tr h="512064">
-                <a:tc>
-                  <a:txBody>
-                    <a:bodyPr/>
-                    <a:lstStyle/>
-                    <a:p>
-                      <a:pPr algn="ctr"/>
-                      <a:r>
-                        <a:rPr sz="1400" b="1">
-                          <a:solidFill>
-                            <a:srgbClr val="212121"/>
-                          </a:solidFill>
-                          <a:latin typeface="맑은 고딕"/>
-                        </a:rPr>
-                        <a:t>고령자 중시</a:t>
-                      </a:r>
-                    </a:p>
-                  </a:txBody>
-                  <a:tcPr/>
-                </a:tc>
-                <a:tc>
-                  <a:txBody>
-                    <a:bodyPr/>
-                    <a:lstStyle/>
-                    <a:p>
-                      <a:pPr algn="ctr"/>
-                      <a:r>
-                        <a:rPr sz="1400" b="1">
-                          <a:solidFill>
-                            <a:srgbClr val="212121"/>
-                          </a:solidFill>
-                          <a:latin typeface="맑은 고딕"/>
-                        </a:rPr>
-                        <a:t>vuln 0.45</a:t>
-                      </a:r>
-                    </a:p>
-                  </a:txBody>
-                  <a:tcPr/>
-                </a:tc>
-                <a:tc>
-                  <a:txBody>
-                    <a:bodyPr/>
-                    <a:lstStyle/>
-                    <a:p>
-                      <a:pPr algn="ctr"/>
-                      <a:r>
-                        <a:rPr sz="1400" b="1">
-                          <a:solidFill>
-                            <a:srgbClr val="212121"/>
-                          </a:solidFill>
-                          <a:latin typeface="맑은 고딕"/>
-                        </a:rPr>
-                        <a:t>0.567</a:t>
-                      </a:r>
-                    </a:p>
-                  </a:txBody>
-                  <a:tcPr/>
-                </a:tc>
-                <a:tc>
-                  <a:txBody>
-                    <a:bodyPr/>
-                    <a:lstStyle/>
-                    <a:p>
-                      <a:pPr algn="ctr"/>
-                      <a:r>
-                        <a:rPr sz="1400" b="1">
-                          <a:solidFill>
-                            <a:srgbClr val="212121"/>
-                          </a:solidFill>
-                          <a:latin typeface="맑은 고딕"/>
-                        </a:rPr>
-                        <a:t>4곳 독점</a:t>
-                      </a:r>
-                    </a:p>
-                  </a:txBody>
-                  <a:tcPr/>
-                </a:tc>
-              </a:tr>
-              <a:tr h="512064">
-                <a:tc>
-                  <a:txBody>
-                    <a:bodyPr/>
-                    <a:lstStyle/>
-                    <a:p>
-                      <a:pPr algn="ctr"/>
-                      <a:r>
-                        <a:rPr sz="1400" b="0">
-                          <a:solidFill>
-                            <a:srgbClr val="212121"/>
-                          </a:solidFill>
-                          <a:latin typeface="맑은 고딕"/>
-                        </a:rPr>
-                        <a:t>폭염 중시</a:t>
-                      </a:r>
-                    </a:p>
-                  </a:txBody>
-                  <a:tcPr/>
-                </a:tc>
-                <a:tc>
-                  <a:txBody>
-                    <a:bodyPr/>
-                    <a:lstStyle/>
-                    <a:p>
-                      <a:pPr algn="ctr"/>
-                      <a:r>
-                        <a:rPr sz="1400" b="0">
-                          <a:solidFill>
-                            <a:srgbClr val="212121"/>
-                          </a:solidFill>
-                          <a:latin typeface="맑은 고딕"/>
-                        </a:rPr>
-                        <a:t>lst 0.45</a:t>
-                      </a:r>
-                    </a:p>
-                  </a:txBody>
-                  <a:tcPr/>
-                </a:tc>
-                <a:tc>
-                  <a:txBody>
-                    <a:bodyPr/>
-                    <a:lstStyle/>
-                    <a:p>
-                      <a:pPr algn="ctr"/>
-                      <a:r>
-                        <a:rPr sz="1400" b="0">
-                          <a:solidFill>
-                            <a:srgbClr val="212121"/>
-                          </a:solidFill>
-                          <a:latin typeface="맑은 고딕"/>
-                        </a:rPr>
-                        <a:t>0.617</a:t>
-                      </a:r>
-                    </a:p>
-                  </a:txBody>
-                  <a:tcPr/>
-                </a:tc>
-                <a:tc>
-                  <a:txBody>
-                    <a:bodyPr/>
-                    <a:lstStyle/>
-                    <a:p>
-                      <a:pPr algn="ctr"/>
-                      <a:r>
-                        <a:rPr sz="1400" b="0">
-                          <a:solidFill>
-                            <a:srgbClr val="212121"/>
-                          </a:solidFill>
-                          <a:latin typeface="맑은 고딕"/>
-                        </a:rPr>
-                        <a:t>0곳</a:t>
-                      </a:r>
-                    </a:p>
-                  </a:txBody>
-                  <a:tcPr/>
-                </a:tc>
-              </a:tr>
-              <a:tr h="512064">
-                <a:tc>
-                  <a:txBody>
-                    <a:bodyPr/>
-                    <a:lstStyle/>
-                    <a:p>
-                      <a:pPr algn="ctr"/>
-                      <a:r>
-                        <a:rPr sz="1400" b="1">
-                          <a:solidFill>
-                            <a:srgbClr val="212121"/>
-                          </a:solidFill>
-                          <a:latin typeface="맑은 고딕"/>
-                        </a:rPr>
-                        <a:t>유동인구 중시</a:t>
-                      </a:r>
-                    </a:p>
-                  </a:txBody>
-                  <a:tcPr/>
-                </a:tc>
-                <a:tc>
-                  <a:txBody>
-                    <a:bodyPr/>
-                    <a:lstStyle/>
-                    <a:p>
-                      <a:pPr algn="ctr"/>
-                      <a:r>
-                        <a:rPr sz="1400" b="1">
-                          <a:solidFill>
-                            <a:srgbClr val="212121"/>
-                          </a:solidFill>
-                          <a:latin typeface="맑은 고딕"/>
-                        </a:rPr>
-                        <a:t>pop 0.45</a:t>
-                      </a:r>
-                    </a:p>
-                  </a:txBody>
-                  <a:tcPr/>
-                </a:tc>
-                <a:tc>
-                  <a:txBody>
-                    <a:bodyPr/>
-                    <a:lstStyle/>
-                    <a:p>
-                      <a:pPr algn="ctr"/>
-                      <a:r>
-                        <a:rPr sz="1400" b="1">
-                          <a:solidFill>
-                            <a:srgbClr val="212121"/>
-                          </a:solidFill>
-                          <a:latin typeface="맑은 고딕"/>
-                        </a:rPr>
-                        <a:t>0.633</a:t>
-                      </a:r>
-                    </a:p>
-                  </a:txBody>
-                  <a:tcPr/>
-                </a:tc>
-                <a:tc>
-                  <a:txBody>
-                    <a:bodyPr/>
-                    <a:lstStyle/>
-                    <a:p>
-                      <a:pPr algn="ctr"/>
-                      <a:r>
-                        <a:rPr sz="1400" b="1">
-                          <a:solidFill>
-                            <a:srgbClr val="212121"/>
-                          </a:solidFill>
-                          <a:latin typeface="맑은 고딕"/>
-                        </a:rPr>
-                        <a:t>3곳 독점</a:t>
-                      </a:r>
-                    </a:p>
-                  </a:txBody>
-                  <a:tcPr/>
-                </a:tc>
-              </a:tr>
-            </a:tbl>
-          </a:graphicData>
-        </a:graphic>
-      </p:graphicFrame>
-      <p:sp>
-        <p:nvSpPr>
-          <p:cNvPr id="6" name="TextBox 5"/>
+              <a:t>딥러닝 zero-shot segmentation으로 동작구 건물 자동 추출</a:t>
+            </a:r>
+          </a:p>
+        </p:txBody>
+      </p:sp>
+      <p:sp>
+        <p:nvSpPr>
+          <p:cNvPr id="5" name="TextBox 4"/>
           <p:cNvSpPr txBox="1"/>
           <p:nvPr/>
         </p:nvSpPr>
         <p:spPr>
           <a:xfrm>
-            <a:off x="685800" y="4572000"/>
-            <a:ext cx="10972800" cy="457200"/>
+            <a:off x="685800" y="1737360"/>
+            <a:ext cx="5943600" cy="4114800"/>
           </a:xfrm>
           <a:prstGeom prst="rect">
             <a:avLst/>
@@ -8510,15 +9360,265 @@
           </a:bodyPr>
           <a:lstStyle/>
           <a:p>
-            <a:pPr algn="l"/>
+            <a:pPr>
+              <a:spcAft>
+                <a:spcPts val="600"/>
+              </a:spcAft>
+            </a:pPr>
+            <a:r>
+              <a:rPr sz="1400" b="0">
+                <a:solidFill>
+                  <a:srgbClr val="212121"/>
+                </a:solidFill>
+                <a:latin typeface="맑은 고딕"/>
+              </a:rPr>
+              <a:t>• V-World WMTS z=15 항공사진 → 동작구 BBOX 48 타일 합성</a:t>
+            </a:r>
+          </a:p>
+          <a:p>
+            <a:pPr>
+              <a:spcAft>
+                <a:spcPts val="600"/>
+              </a:spcAft>
+            </a:pPr>
+            <a:r>
+              <a:rPr sz="1400" b="0">
+                <a:solidFill>
+                  <a:srgbClr val="212121"/>
+                </a:solidFill>
+                <a:latin typeface="맑은 고딕"/>
+              </a:rPr>
+              <a:t>• Mobile-SAM (Meta, 2023) — 40MB 경량 SAM, CPU 추론 가능</a:t>
+            </a:r>
+          </a:p>
+          <a:p>
+            <a:pPr>
+              <a:spcAft>
+                <a:spcPts val="600"/>
+              </a:spcAft>
+            </a:pPr>
+            <a:r>
+              <a:rPr sz="1400" b="0">
+                <a:solidFill>
+                  <a:srgbClr val="212121"/>
+                </a:solidFill>
+                <a:latin typeface="맑은 고딕"/>
+              </a:rPr>
+              <a:t>• 필터: 면적 200~30k px², 종횡비 0.2~5, 평균 밝기 80~220</a:t>
+            </a:r>
+          </a:p>
+          <a:p>
+            <a:pPr>
+              <a:spcAft>
+                <a:spcPts val="600"/>
+              </a:spcAft>
+            </a:pPr>
+            <a:r>
+              <a:rPr sz="1400" b="0">
+                <a:solidFill>
+                  <a:srgbClr val="212121"/>
+                </a:solidFill>
+                <a:latin typeface="맑은 고딕"/>
+              </a:rPr>
+              <a:t>• 결과: 더미 19동 → 실측 30동 자동 추출</a:t>
+            </a:r>
+          </a:p>
+          <a:p>
+            <a:pPr>
+              <a:spcAft>
+                <a:spcPts val="600"/>
+              </a:spcAft>
+            </a:pPr>
+            <a:r>
+              <a:rPr sz="1400" b="0">
+                <a:solidFill>
+                  <a:srgbClr val="212121"/>
+                </a:solidFill>
+                <a:latin typeface="맑은 고딕"/>
+              </a:rPr>
+              <a:t>• 픽셀 → EPSG:3857 → WGS84 polygon 변환 → buildings.geojson</a:t>
+            </a:r>
+          </a:p>
+          <a:p>
+            <a:pPr>
+              <a:spcAft>
+                <a:spcPts val="600"/>
+              </a:spcAft>
+            </a:pPr>
+            <a:r>
+              <a:rPr sz="1400" b="0">
+                <a:solidFill>
+                  <a:srgbClr val="212121"/>
+                </a:solidFill>
+                <a:latin typeface="맑은 고딕"/>
+              </a:rPr>
+              <a:t>• 파이프라인 첫 실행 시 자동 1회, 이후 캐시 사용</a:t>
+            </a:r>
+          </a:p>
+        </p:txBody>
+      </p:sp>
+      <p:sp>
+        <p:nvSpPr>
+          <p:cNvPr id="6" name="Rounded Rectangle 5"/>
+          <p:cNvSpPr/>
+          <p:nvPr/>
+        </p:nvSpPr>
+        <p:spPr>
+          <a:xfrm>
+            <a:off x="6858000" y="1737360"/>
+            <a:ext cx="4846320" cy="4114800"/>
+          </a:xfrm>
+          <a:prstGeom prst="roundRect">
+            <a:avLst/>
+          </a:prstGeom>
+          <a:solidFill>
+            <a:srgbClr val="F5F8FD"/>
+          </a:solidFill>
+          <a:ln w="19050">
+            <a:solidFill>
+              <a:srgbClr val="1E88E5"/>
+            </a:solidFill>
+          </a:ln>
+        </p:spPr>
+        <p:style>
+          <a:lnRef idx="1">
+            <a:schemeClr val="accent1"/>
+          </a:lnRef>
+          <a:fillRef idx="3">
+            <a:schemeClr val="accent1"/>
+          </a:fillRef>
+          <a:effectRef idx="2">
+            <a:schemeClr val="accent1"/>
+          </a:effectRef>
+          <a:fontRef idx="minor">
+            <a:schemeClr val="lt1"/>
+          </a:fontRef>
+        </p:style>
+        <p:txBody>
+          <a:bodyPr rtlCol="0" anchor="ctr" wrap="square" lIns="274320" tIns="274320"/>
+          <a:lstStyle/>
+          <a:p>
+            <a:pPr algn="ctr"/>
             <a:r>
               <a:rPr sz="1400" b="1">
                 <a:solidFill>
-                  <a:srgbClr val="E53935"/>
-                </a:solidFill>
-                <a:latin typeface="맑은 고딕"/>
-              </a:rPr>
-              <a:t>💡 자연그늘 활성화로 고령자 시나리오 최고 Score 0.580 → 0.567 (페널티 의도대로 작동)</a:t>
+                  <a:srgbClr val="1E88E5"/>
+                </a:solidFill>
+                <a:latin typeface="맑은 고딕"/>
+              </a:rPr>
+              <a:t>📁 output/cv_buildings_overlay.png</a:t>
+            </a:r>
+          </a:p>
+          <a:p>
+            <a:pPr>
+              <a:spcBef>
+                <a:spcPts val="200"/>
+              </a:spcBef>
+            </a:pPr>
+            <a:r>
+              <a:rPr sz="1200" b="0">
+                <a:solidFill>
+                  <a:srgbClr val="212121"/>
+                </a:solidFill>
+                <a:latin typeface="맑은 고딕"/>
+              </a:rPr>
+              <a:t/>
+            </a:r>
+          </a:p>
+          <a:p>
+            <a:pPr>
+              <a:spcBef>
+                <a:spcPts val="200"/>
+              </a:spcBef>
+            </a:pPr>
+            <a:r>
+              <a:rPr sz="1200" b="0">
+                <a:solidFill>
+                  <a:srgbClr val="212121"/>
+                </a:solidFill>
+                <a:latin typeface="맑은 고딕"/>
+              </a:rPr>
+              <a:t>위성 이미지 (2048×1536)</a:t>
+            </a:r>
+          </a:p>
+          <a:p>
+            <a:pPr>
+              <a:spcBef>
+                <a:spcPts val="200"/>
+              </a:spcBef>
+            </a:pPr>
+            <a:r>
+              <a:rPr sz="1200" b="0">
+                <a:solidFill>
+                  <a:srgbClr val="212121"/>
+                </a:solidFill>
+                <a:latin typeface="맑은 고딕"/>
+              </a:rPr>
+              <a:t>+ SAM 마스크 노란색 오버레이</a:t>
+            </a:r>
+          </a:p>
+          <a:p>
+            <a:pPr>
+              <a:spcBef>
+                <a:spcPts val="200"/>
+              </a:spcBef>
+            </a:pPr>
+            <a:r>
+              <a:rPr sz="1200" b="0">
+                <a:solidFill>
+                  <a:srgbClr val="212121"/>
+                </a:solidFill>
+                <a:latin typeface="맑은 고딕"/>
+              </a:rPr>
+              <a:t>+ 추출 polygon 녹색 외곽선</a:t>
+            </a:r>
+          </a:p>
+          <a:p>
+            <a:pPr>
+              <a:spcBef>
+                <a:spcPts val="200"/>
+              </a:spcBef>
+            </a:pPr>
+            <a:r>
+              <a:rPr sz="1200" b="0">
+                <a:solidFill>
+                  <a:srgbClr val="212121"/>
+                </a:solidFill>
+                <a:latin typeface="맑은 고딕"/>
+              </a:rPr>
+              <a:t/>
+            </a:r>
+          </a:p>
+          <a:p>
+            <a:pPr>
+              <a:spcBef>
+                <a:spcPts val="200"/>
+              </a:spcBef>
+            </a:pPr>
+            <a:r>
+              <a:rPr sz="1200" b="0">
+                <a:solidFill>
+                  <a:srgbClr val="212121"/>
+                </a:solidFill>
+                <a:latin typeface="맑은 고딕"/>
+              </a:rPr>
+              <a:t>30동 분포: 노량진·사당·이수·</a:t>
+            </a:r>
+          </a:p>
+          <a:p>
+            <a:pPr>
+              <a:spcBef>
+                <a:spcPts val="200"/>
+              </a:spcBef>
+            </a:pPr>
+            <a:r>
+              <a:rPr sz="1200" b="0">
+                <a:solidFill>
+                  <a:srgbClr val="212121"/>
+                </a:solidFill>
+                <a:latin typeface="맑은 고딕"/>
+              </a:rPr>
+              <a:t>상도로·장승배기·흑석동</a:t>
             </a:r>
           </a:p>
         </p:txBody>
@@ -8531,8 +9631,8 @@
         </p:nvSpPr>
         <p:spPr>
           <a:xfrm>
-            <a:off x="685800" y="5120640"/>
-            <a:ext cx="10972800" cy="457200"/>
+            <a:off x="457200" y="6400800"/>
+            <a:ext cx="9144000" cy="365760"/>
           </a:xfrm>
           <a:prstGeom prst="rect">
             <a:avLst/>
@@ -8547,13 +9647,13 @@
           <a:p>
             <a:pPr algn="l"/>
             <a:r>
-              <a:rPr sz="1400" b="0">
+              <a:rPr sz="1000" b="0">
                 <a:solidFill>
                   <a:srgbClr val="555555"/>
                 </a:solidFill>
                 <a:latin typeface="맑은 고딕"/>
               </a:rPr>
-              <a:t>🎯 "정책이 다르면 답도 다르다" — 그러나 어떤 관점에서도 공통으로 추천되는 입지가 존재한다 (다음 슬라이드)</a:t>
+              <a:t>동작구 여름 그늘막 최적 입지 추천 시스템 · 한영재 · 2025961227</a:t>
             </a:r>
           </a:p>
         </p:txBody>
@@ -8566,8 +9666,8 @@
         </p:nvSpPr>
         <p:spPr>
           <a:xfrm>
-            <a:off x="457200" y="6400800"/>
-            <a:ext cx="9144000" cy="365760"/>
+            <a:off x="11247120" y="6400800"/>
+            <a:ext cx="914400" cy="365760"/>
           </a:xfrm>
           <a:prstGeom prst="rect">
             <a:avLst/>
@@ -8580,7 +9680,7 @@
           </a:bodyPr>
           <a:lstStyle/>
           <a:p>
-            <a:pPr algn="l"/>
+            <a:pPr algn="r"/>
             <a:r>
               <a:rPr sz="1000" b="0">
                 <a:solidFill>
@@ -8588,42 +9688,7 @@
                 </a:solidFill>
                 <a:latin typeface="맑은 고딕"/>
               </a:rPr>
-              <a:t>동작구 여름 그늘막 최적 입지 추천 시스템 · 한영재 · 2025961227</a:t>
-            </a:r>
-          </a:p>
-        </p:txBody>
-      </p:sp>
-      <p:sp>
-        <p:nvSpPr>
-          <p:cNvPr id="9" name="TextBox 8"/>
-          <p:cNvSpPr txBox="1"/>
-          <p:nvPr/>
-        </p:nvSpPr>
-        <p:spPr>
-          <a:xfrm>
-            <a:off x="11247120" y="6400800"/>
-            <a:ext cx="914400" cy="365760"/>
-          </a:xfrm>
-          <a:prstGeom prst="rect">
-            <a:avLst/>
-          </a:prstGeom>
-          <a:noFill/>
-        </p:spPr>
-        <p:txBody>
-          <a:bodyPr wrap="square">
-            <a:spAutoFit/>
-          </a:bodyPr>
-          <a:lstStyle/>
-          <a:p>
-            <a:pPr algn="r"/>
-            <a:r>
-              <a:rPr sz="1000" b="0">
-                <a:solidFill>
-                  <a:srgbClr val="555555"/>
-                </a:solidFill>
-                <a:latin typeface="맑은 고딕"/>
-              </a:rPr>
-              <a:t>8 / 12</a:t>
+              <a:t>8 / 14</a:t>
             </a:r>
           </a:p>
         </p:txBody>
@@ -8719,7 +9784,7 @@
                 </a:solidFill>
                 <a:latin typeface="맑은 고딕"/>
               </a:rPr>
-              <a:t>강건 입지 · Robust Location</a:t>
+              <a:t>CV-B · 거리뷰 + SegFormer (CityScapes)</a:t>
             </a:r>
           </a:p>
         </p:txBody>
@@ -8754,32 +9819,133 @@
                 </a:solidFill>
                 <a:latin typeface="맑은 고딕"/>
               </a:rPr>
-              <a:t>4개 시나리오 공통 추천 = 어떤 정책 관점에서도 필수</a:t>
-            </a:r>
-          </a:p>
-        </p:txBody>
-      </p:sp>
-      <p:sp>
-        <p:nvSpPr>
-          <p:cNvPr id="5" name="Rounded Rectangle 4"/>
+              <a:t>지면 시점에서 본 보행 환경을 19-class 의미 분할</a:t>
+            </a:r>
+          </a:p>
+        </p:txBody>
+      </p:sp>
+      <p:sp>
+        <p:nvSpPr>
+          <p:cNvPr id="5" name="TextBox 4"/>
+          <p:cNvSpPr txBox="1"/>
+          <p:nvPr/>
+        </p:nvSpPr>
+        <p:spPr>
+          <a:xfrm>
+            <a:off x="685800" y="1737360"/>
+            <a:ext cx="5943600" cy="4114800"/>
+          </a:xfrm>
+          <a:prstGeom prst="rect">
+            <a:avLst/>
+          </a:prstGeom>
+          <a:noFill/>
+        </p:spPr>
+        <p:txBody>
+          <a:bodyPr wrap="square">
+            <a:spAutoFit/>
+          </a:bodyPr>
+          <a:lstStyle/>
+          <a:p>
+            <a:pPr>
+              <a:spcAft>
+                <a:spcPts val="600"/>
+              </a:spcAft>
+            </a:pPr>
+            <a:r>
+              <a:rPr sz="1400" b="0">
+                <a:solidFill>
+                  <a:srgbClr val="212121"/>
+                </a:solidFill>
+                <a:latin typeface="맑은 고딕"/>
+              </a:rPr>
+              <a:t>• Mapillary 거리뷰 — 동작구 BBOX 4×4 분할 검색 → 1,249장 발견</a:t>
+            </a:r>
+          </a:p>
+          <a:p>
+            <a:pPr>
+              <a:spcAft>
+                <a:spcPts val="600"/>
+              </a:spcAft>
+            </a:pPr>
+            <a:r>
+              <a:rPr sz="1400" b="0">
+                <a:solidFill>
+                  <a:srgbClr val="212121"/>
+                </a:solidFill>
+                <a:latin typeface="맑은 고딕"/>
+              </a:rPr>
+              <a:t>• 후보 19개 격자에 nearest 매핑 → 격자당 ≤3장 다운로드</a:t>
+            </a:r>
+          </a:p>
+          <a:p>
+            <a:pPr>
+              <a:spcAft>
+                <a:spcPts val="600"/>
+              </a:spcAft>
+            </a:pPr>
+            <a:r>
+              <a:rPr sz="1400" b="0">
+                <a:solidFill>
+                  <a:srgbClr val="212121"/>
+                </a:solidFill>
+                <a:latin typeface="맑은 고딕"/>
+              </a:rPr>
+              <a:t>• HuggingFace SegFormer-b0 (CityScapes 19 classes pretrained)</a:t>
+            </a:r>
+          </a:p>
+          <a:p>
+            <a:pPr>
+              <a:spcAft>
+                <a:spcPts val="600"/>
+              </a:spcAft>
+            </a:pPr>
+            <a:r>
+              <a:rPr sz="1400" b="0">
+                <a:solidFill>
+                  <a:srgbClr val="212121"/>
+                </a:solidFill>
+                <a:latin typeface="맑은 고딕"/>
+              </a:rPr>
+              <a:t>• 주요 클래스: building · vegetation · road · sidewalk · sky</a:t>
+            </a:r>
+          </a:p>
+          <a:p>
+            <a:pPr>
+              <a:spcAft>
+                <a:spcPts val="600"/>
+              </a:spcAft>
+            </a:pPr>
+            <a:r>
+              <a:rPr sz="1400" b="0">
+                <a:solidFill>
+                  <a:srgbClr val="212121"/>
+                </a:solidFill>
+                <a:latin typeface="맑은 고딕"/>
+              </a:rPr>
+              <a:t>• Treepedia(MIT)·Place Pulse 류 선행연구의 그늘막 응용</a:t>
+            </a:r>
+          </a:p>
+        </p:txBody>
+      </p:sp>
+      <p:sp>
+        <p:nvSpPr>
+          <p:cNvPr id="6" name="Rounded Rectangle 5"/>
           <p:cNvSpPr/>
           <p:nvPr/>
         </p:nvSpPr>
         <p:spPr>
           <a:xfrm>
-            <a:off x="685800" y="1828800"/>
-            <a:ext cx="3611880" cy="2743200"/>
+            <a:off x="6858000" y="1737360"/>
+            <a:ext cx="4846320" cy="1828800"/>
           </a:xfrm>
           <a:prstGeom prst="roundRect">
             <a:avLst/>
           </a:prstGeom>
           <a:solidFill>
-            <a:srgbClr val="FAFAFA"/>
+            <a:srgbClr val="212121"/>
           </a:solidFill>
-          <a:ln w="31750">
-            <a:solidFill>
-              <a:srgbClr val="8E24AA"/>
-            </a:solidFill>
+          <a:ln>
+            <a:noFill/>
           </a:ln>
         </p:spPr>
         <p:style>
@@ -8802,85 +9968,73 @@
           <a:p>
             <a:pPr algn="ctr"/>
             <a:r>
-              <a:rPr sz="1600" b="1">
-                <a:solidFill>
-                  <a:srgbClr val="8E24AA"/>
-                </a:solidFill>
-                <a:latin typeface="맑은 고딕"/>
-              </a:rPr>
-              <a:t>#1</a:t>
-            </a:r>
-          </a:p>
-          <a:p>
-            <a:pPr algn="ctr">
-              <a:spcBef>
-                <a:spcPts val="600"/>
-              </a:spcBef>
-            </a:pPr>
-            <a:r>
-              <a:rPr sz="2800" b="1">
-                <a:solidFill>
-                  <a:srgbClr val="212121"/>
-                </a:solidFill>
-                <a:latin typeface="맑은 고딕"/>
-              </a:rPr>
-              <a:t>상도로</a:t>
-            </a:r>
-          </a:p>
-          <a:p>
-            <a:pPr algn="ctr">
-              <a:spcBef>
-                <a:spcPts val="400"/>
-              </a:spcBef>
-            </a:pPr>
-            <a:r>
-              <a:rPr sz="1600" b="0">
-                <a:solidFill>
-                  <a:srgbClr val="555555"/>
-                </a:solidFill>
-                <a:latin typeface="맑은 고딕"/>
-              </a:rPr>
-              <a:t>상도3동 주거밀집</a:t>
-            </a:r>
-          </a:p>
-          <a:p>
-            <a:pPr algn="ctr">
-              <a:spcBef>
-                <a:spcPts val="1000"/>
-              </a:spcBef>
-            </a:pPr>
+              <a:rPr sz="1400" b="1">
+                <a:solidFill>
+                  <a:srgbClr val="FFEE58"/>
+                </a:solidFill>
+                <a:latin typeface="맑은 고딕"/>
+              </a:rPr>
+              <a:t>그늘 결핍 지수</a:t>
+            </a:r>
+          </a:p>
+          <a:p>
+            <a:pPr algn="ctr"/>
             <a:r>
               <a:rPr sz="1200" b="0">
                 <a:solidFill>
-                  <a:srgbClr val="555555"/>
-                </a:solidFill>
-                <a:latin typeface="맑은 고딕"/>
-              </a:rPr>
-              <a:t>37.4977, 126.9341</a:t>
-            </a:r>
-          </a:p>
-        </p:txBody>
-      </p:sp>
-      <p:sp>
-        <p:nvSpPr>
-          <p:cNvPr id="6" name="Rounded Rectangle 5"/>
+                  <a:srgbClr val="CCCCCC"/>
+                </a:solidFill>
+                <a:latin typeface="맑은 고딕"/>
+              </a:rPr>
+              <a:t>deficit =</a:t>
+            </a:r>
+          </a:p>
+          <a:p>
+            <a:pPr algn="ctr"/>
+            <a:r>
+              <a:rPr sz="1400" b="1">
+                <a:solidFill>
+                  <a:srgbClr val="FFFFFF"/>
+                </a:solidFill>
+                <a:latin typeface="맑은 고딕"/>
+              </a:rPr>
+              <a:t>(road + sidewalk)</a:t>
+            </a:r>
+          </a:p>
+          <a:p>
+            <a:pPr algn="ctr"/>
+            <a:r>
+              <a:rPr sz="1400" b="1">
+                <a:solidFill>
+                  <a:srgbClr val="FFFFFF"/>
+                </a:solidFill>
+                <a:latin typeface="맑은 고딕"/>
+              </a:rPr>
+              <a:t>× (1 − building − vegetation)</a:t>
+            </a:r>
+          </a:p>
+        </p:txBody>
+      </p:sp>
+      <p:sp>
+        <p:nvSpPr>
+          <p:cNvPr id="7" name="Rounded Rectangle 6"/>
           <p:cNvSpPr/>
           <p:nvPr/>
         </p:nvSpPr>
         <p:spPr>
           <a:xfrm>
-            <a:off x="4434840" y="1828800"/>
-            <a:ext cx="3611880" cy="2743200"/>
+            <a:off x="6858000" y="3749039"/>
+            <a:ext cx="4846320" cy="2103120"/>
           </a:xfrm>
           <a:prstGeom prst="roundRect">
             <a:avLst/>
           </a:prstGeom>
           <a:solidFill>
-            <a:srgbClr val="FAFAFA"/>
+            <a:srgbClr val="FFF4E5"/>
           </a:solidFill>
-          <a:ln w="31750">
+          <a:ln w="19050">
             <a:solidFill>
-              <a:srgbClr val="8E24AA"/>
+              <a:srgbClr val="FB8C00"/>
             </a:solidFill>
           </a:ln>
         </p:spPr>
@@ -8899,168 +10053,66 @@
           </a:fontRef>
         </p:style>
         <p:txBody>
-          <a:bodyPr rtlCol="0" anchor="ctr" wrap="square" lIns="182880" tIns="182880"/>
+          <a:bodyPr rtlCol="0" anchor="ctr" wrap="square" lIns="228600" tIns="182880"/>
           <a:lstStyle/>
           <a:p>
             <a:pPr algn="ctr"/>
             <a:r>
-              <a:rPr sz="1600" b="1">
-                <a:solidFill>
-                  <a:srgbClr val="8E24AA"/>
-                </a:solidFill>
-                <a:latin typeface="맑은 고딕"/>
-              </a:rPr>
-              <a:t>#2</a:t>
-            </a:r>
-          </a:p>
-          <a:p>
-            <a:pPr algn="ctr">
-              <a:spcBef>
-                <a:spcPts val="600"/>
-              </a:spcBef>
-            </a:pPr>
-            <a:r>
-              <a:rPr sz="2800" b="1">
-                <a:solidFill>
-                  <a:srgbClr val="212121"/>
-                </a:solidFill>
-                <a:latin typeface="맑은 고딕"/>
-              </a:rPr>
-              <a:t>상도로</a:t>
-            </a:r>
-          </a:p>
-          <a:p>
-            <a:pPr algn="ctr">
+              <a:rPr sz="1400" b="1">
+                <a:solidFill>
+                  <a:srgbClr val="FB8C00"/>
+                </a:solidFill>
+                <a:latin typeface="맑은 고딕"/>
+              </a:rPr>
+              <a:t>📊 결과</a:t>
+            </a:r>
+          </a:p>
+          <a:p>
+            <a:pPr>
               <a:spcBef>
                 <a:spcPts val="400"/>
               </a:spcBef>
             </a:pPr>
             <a:r>
-              <a:rPr sz="1600" b="0">
-                <a:solidFill>
-                  <a:srgbClr val="555555"/>
-                </a:solidFill>
-                <a:latin typeface="맑은 고딕"/>
-              </a:rPr>
-              <a:t>상도3동 주거밀집</a:t>
-            </a:r>
-          </a:p>
-          <a:p>
-            <a:pPr algn="ctr">
-              <a:spcBef>
-                <a:spcPts val="1000"/>
-              </a:spcBef>
-            </a:pPr>
-            <a:r>
-              <a:rPr sz="1200" b="0">
-                <a:solidFill>
-                  <a:srgbClr val="555555"/>
-                </a:solidFill>
-                <a:latin typeface="맑은 고딕"/>
-              </a:rPr>
-              <a:t>37.4986, 126.9353</a:t>
-            </a:r>
-          </a:p>
-        </p:txBody>
-      </p:sp>
-      <p:sp>
-        <p:nvSpPr>
-          <p:cNvPr id="7" name="Rounded Rectangle 6"/>
-          <p:cNvSpPr/>
-          <p:nvPr/>
-        </p:nvSpPr>
-        <p:spPr>
-          <a:xfrm>
-            <a:off x="8183880" y="1828800"/>
-            <a:ext cx="3611880" cy="2743200"/>
-          </a:xfrm>
-          <a:prstGeom prst="roundRect">
-            <a:avLst/>
-          </a:prstGeom>
-          <a:solidFill>
-            <a:srgbClr val="FAFAFA"/>
-          </a:solidFill>
-          <a:ln w="31750">
-            <a:solidFill>
-              <a:srgbClr val="E53935"/>
-            </a:solidFill>
-          </a:ln>
-        </p:spPr>
-        <p:style>
-          <a:lnRef idx="1">
-            <a:schemeClr val="accent1"/>
-          </a:lnRef>
-          <a:fillRef idx="3">
-            <a:schemeClr val="accent1"/>
-          </a:fillRef>
-          <a:effectRef idx="2">
-            <a:schemeClr val="accent1"/>
-          </a:effectRef>
-          <a:fontRef idx="minor">
-            <a:schemeClr val="lt1"/>
-          </a:fontRef>
-        </p:style>
-        <p:txBody>
-          <a:bodyPr rtlCol="0" anchor="ctr" wrap="square" lIns="182880" tIns="182880"/>
-          <a:lstStyle/>
-          <a:p>
-            <a:pPr algn="ctr"/>
-            <a:r>
-              <a:rPr sz="1600" b="1">
-                <a:solidFill>
-                  <a:srgbClr val="E53935"/>
-                </a:solidFill>
-                <a:latin typeface="맑은 고딕"/>
-              </a:rPr>
-              <a:t>#3</a:t>
-            </a:r>
-          </a:p>
-          <a:p>
-            <a:pPr algn="ctr">
-              <a:spcBef>
-                <a:spcPts val="600"/>
-              </a:spcBef>
-            </a:pPr>
-            <a:r>
-              <a:rPr sz="2800" b="1">
+              <a:rPr sz="1300" b="0">
                 <a:solidFill>
                   <a:srgbClr val="212121"/>
                 </a:solidFill>
                 <a:latin typeface="맑은 고딕"/>
               </a:rPr>
-              <a:t>동작대로</a:t>
-            </a:r>
-          </a:p>
-          <a:p>
-            <a:pPr algn="ctr">
+              <a:t>• TOP10 평균 deficit: 0.127</a:t>
+            </a:r>
+          </a:p>
+          <a:p>
+            <a:pPr>
               <a:spcBef>
                 <a:spcPts val="400"/>
               </a:spcBef>
             </a:pPr>
             <a:r>
-              <a:rPr sz="1600" b="0">
-                <a:solidFill>
-                  <a:srgbClr val="555555"/>
-                </a:solidFill>
-                <a:latin typeface="맑은 고딕"/>
-              </a:rPr>
-              <a:t>사당-이수 축</a:t>
-            </a:r>
-          </a:p>
-          <a:p>
-            <a:pPr algn="ctr">
+              <a:rPr sz="1300" b="0">
+                <a:solidFill>
+                  <a:srgbClr val="212121"/>
+                </a:solidFill>
+                <a:latin typeface="맑은 고딕"/>
+              </a:rPr>
+              <a:t>• Score 식 6번째 피처 통합</a:t>
+            </a:r>
+          </a:p>
+          <a:p>
+            <a:pPr>
               <a:spcBef>
-                <a:spcPts val="1000"/>
+                <a:spcPts val="400"/>
               </a:spcBef>
             </a:pPr>
             <a:r>
-              <a:rPr sz="1200" b="0">
-                <a:solidFill>
-                  <a:srgbClr val="555555"/>
-                </a:solidFill>
-                <a:latin typeface="맑은 고딕"/>
-              </a:rPr>
-              <a:t>37.4907, 126.9647</a:t>
+              <a:rPr sz="1300" b="0">
+                <a:solidFill>
+                  <a:srgbClr val="212121"/>
+                </a:solidFill>
+                <a:latin typeface="맑은 고딕"/>
+              </a:rPr>
+              <a:t>• 신규 시나리오 추가: 보행환경_중시</a:t>
             </a:r>
           </a:p>
         </p:txBody>
@@ -9073,8 +10125,8 @@
         </p:nvSpPr>
         <p:spPr>
           <a:xfrm>
-            <a:off x="685800" y="4937760"/>
-            <a:ext cx="10972800" cy="457200"/>
+            <a:off x="457200" y="6400800"/>
+            <a:ext cx="9144000" cy="365760"/>
           </a:xfrm>
           <a:prstGeom prst="rect">
             <a:avLst/>
@@ -9089,13 +10141,13 @@
           <a:p>
             <a:pPr algn="l"/>
             <a:r>
-              <a:rPr sz="1600" b="1">
-                <a:solidFill>
-                  <a:srgbClr val="1E88E5"/>
-                </a:solidFill>
-                <a:latin typeface="맑은 고딕"/>
-              </a:rPr>
-              <a:t>정책적 함의: 예산 제약 시 이 3곳이 최우선 설치 대상</a:t>
+              <a:rPr sz="1000" b="0">
+                <a:solidFill>
+                  <a:srgbClr val="555555"/>
+                </a:solidFill>
+                <a:latin typeface="맑은 고딕"/>
+              </a:rPr>
+              <a:t>동작구 여름 그늘막 최적 입지 추천 시스템 · 한영재 · 2025961227</a:t>
             </a:r>
           </a:p>
         </p:txBody>
@@ -9108,8 +10160,8 @@
         </p:nvSpPr>
         <p:spPr>
           <a:xfrm>
-            <a:off x="685800" y="5486400"/>
-            <a:ext cx="10972800" cy="457200"/>
+            <a:off x="11247120" y="6400800"/>
+            <a:ext cx="914400" cy="365760"/>
           </a:xfrm>
           <a:prstGeom prst="rect">
             <a:avLst/>
@@ -9122,85 +10174,15 @@
           </a:bodyPr>
           <a:lstStyle/>
           <a:p>
-            <a:pPr algn="l"/>
-            <a:r>
-              <a:rPr sz="1300" b="0">
+            <a:pPr algn="r"/>
+            <a:r>
+              <a:rPr sz="1000" b="0">
                 <a:solidFill>
                   <a:srgbClr val="555555"/>
                 </a:solidFill>
                 <a:latin typeface="맑은 고딕"/>
               </a:rPr>
-              <a:t>자연그늘 활성화로 4 → 3곳 — 식별력이 더 엄격해졌음</a:t>
-            </a:r>
-          </a:p>
-        </p:txBody>
-      </p:sp>
-      <p:sp>
-        <p:nvSpPr>
-          <p:cNvPr id="10" name="TextBox 9"/>
-          <p:cNvSpPr txBox="1"/>
-          <p:nvPr/>
-        </p:nvSpPr>
-        <p:spPr>
-          <a:xfrm>
-            <a:off x="457200" y="6400800"/>
-            <a:ext cx="9144000" cy="365760"/>
-          </a:xfrm>
-          <a:prstGeom prst="rect">
-            <a:avLst/>
-          </a:prstGeom>
-          <a:noFill/>
-        </p:spPr>
-        <p:txBody>
-          <a:bodyPr wrap="square">
-            <a:spAutoFit/>
-          </a:bodyPr>
-          <a:lstStyle/>
-          <a:p>
-            <a:pPr algn="l"/>
-            <a:r>
-              <a:rPr sz="1000" b="0">
-                <a:solidFill>
-                  <a:srgbClr val="555555"/>
-                </a:solidFill>
-                <a:latin typeface="맑은 고딕"/>
-              </a:rPr>
-              <a:t>동작구 여름 그늘막 최적 입지 추천 시스템 · 한영재 · 2025961227</a:t>
-            </a:r>
-          </a:p>
-        </p:txBody>
-      </p:sp>
-      <p:sp>
-        <p:nvSpPr>
-          <p:cNvPr id="11" name="TextBox 10"/>
-          <p:cNvSpPr txBox="1"/>
-          <p:nvPr/>
-        </p:nvSpPr>
-        <p:spPr>
-          <a:xfrm>
-            <a:off x="11247120" y="6400800"/>
-            <a:ext cx="914400" cy="365760"/>
-          </a:xfrm>
-          <a:prstGeom prst="rect">
-            <a:avLst/>
-          </a:prstGeom>
-          <a:noFill/>
-        </p:spPr>
-        <p:txBody>
-          <a:bodyPr wrap="square">
-            <a:spAutoFit/>
-          </a:bodyPr>
-          <a:lstStyle/>
-          <a:p>
-            <a:pPr algn="r"/>
-            <a:r>
-              <a:rPr sz="1000" b="0">
-                <a:solidFill>
-                  <a:srgbClr val="555555"/>
-                </a:solidFill>
-                <a:latin typeface="맑은 고딕"/>
-              </a:rPr>
-              <a:t>9 / 12</a:t>
+              <a:t>9 / 14</a:t>
             </a:r>
           </a:p>
         </p:txBody>

</xml_diff>